<commit_message>
Upgrade slide deck to premium card layout with screenshots and Calibri/Arial fonts
</commit_message>
<xml_diff>
--- a/Altura_Household_Convergence_Strategy.pptx
+++ b/Altura_Household_Convergence_Strategy.pptx
@@ -10,7 +10,6 @@
   <p:sldIdLst>
     <p:sldId id="256" r:id="rId2"/>
     <p:sldId id="257" r:id="rId3"/>
-    <p:sldId id="258" r:id="rId4"/>
     <p:sldId id="260" r:id="rId5"/>
     <p:sldId id="261" r:id="rId6"/>
     <p:sldId id="262" r:id="rId7"/>
@@ -20,6 +19,7 @@
     <p:sldId id="266" r:id="rId16"/>
     <p:sldId id="267" r:id="rId17"/>
     <p:sldId id="268" r:id="rId18"/>
+    <p:sldId id="269" r:id="rId4"/>
   </p:sldIdLst>
   <p:sldSz cx="9144000" cy="5143500" type="screen16x9"/>
   <p:notesSz cx="6858000" cy="9144000"/>
@@ -913,133 +913,6 @@
         </p:txBody>
       </p:sp>
     </p:spTree>
-  </p:cSld>
-  <p:clrMapOvr>
-    <a:masterClrMapping/>
-  </p:clrMapOvr>
-</p:notes>
-</file>
-
-<file path=ppt/notesSlides/notesSlide3.xml><?xml version="1.0" encoding="utf-8"?>
-<p:notes xmlns:a="http://schemas.openxmlformats.org/drawingml/2006/main" xmlns:r="http://schemas.openxmlformats.org/officeDocument/2006/relationships" xmlns:p="http://schemas.openxmlformats.org/presentationml/2006/main" showMasterSp="0" showMasterPhAnim="0">
-  <p:cSld>
-    <p:spTree>
-      <p:nvGrpSpPr>
-        <p:cNvPr id="1" name="Shape 55">
-          <a:extLst>
-            <a:ext uri="{FF2B5EF4-FFF2-40B4-BE49-F238E27FC236}">
-              <a16:creationId xmlns:a16="http://schemas.microsoft.com/office/drawing/2014/main" id="{9091668D-A8FE-89DA-D5F0-64689047E506}"/>
-            </a:ext>
-          </a:extLst>
-        </p:cNvPr>
-        <p:cNvGrpSpPr/>
-        <p:nvPr/>
-      </p:nvGrpSpPr>
-      <p:grpSpPr>
-        <a:xfrm>
-          <a:off x="0" y="0"/>
-          <a:ext cx="0" cy="0"/>
-          <a:chOff x="0" y="0"/>
-          <a:chExt cx="0" cy="0"/>
-        </a:xfrm>
-      </p:grpSpPr>
-      <p:sp>
-        <p:nvSpPr>
-          <p:cNvPr id="56" name="Google Shape;56;g3f2dfdaf518_0_1:notes">
-            <a:extLst>
-              <a:ext uri="{FF2B5EF4-FFF2-40B4-BE49-F238E27FC236}">
-                <a16:creationId xmlns:a16="http://schemas.microsoft.com/office/drawing/2014/main" id="{B190057C-A0F7-315E-FFE5-3CCFF993A8E9}"/>
-              </a:ext>
-            </a:extLst>
-          </p:cNvPr>
-          <p:cNvSpPr>
-            <a:spLocks noGrp="1" noRot="1" noChangeAspect="1"/>
-          </p:cNvSpPr>
-          <p:nvPr>
-            <p:ph type="sldImg" idx="2"/>
-          </p:nvPr>
-        </p:nvSpPr>
-        <p:spPr>
-          <a:xfrm>
-            <a:off x="381000" y="685800"/>
-            <a:ext cx="6096000" cy="3429000"/>
-          </a:xfrm>
-          <a:custGeom>
-            <a:avLst/>
-            <a:gdLst/>
-            <a:ahLst/>
-            <a:cxnLst/>
-            <a:rect l="l" t="t" r="r" b="b"/>
-            <a:pathLst>
-              <a:path w="120000" h="120000" extrusionOk="0">
-                <a:moveTo>
-                  <a:pt x="0" y="0"/>
-                </a:moveTo>
-                <a:lnTo>
-                  <a:pt x="120000" y="0"/>
-                </a:lnTo>
-                <a:lnTo>
-                  <a:pt x="120000" y="120000"/>
-                </a:lnTo>
-                <a:lnTo>
-                  <a:pt x="0" y="120000"/>
-                </a:lnTo>
-                <a:close/>
-              </a:path>
-            </a:pathLst>
-          </a:custGeom>
-        </p:spPr>
-      </p:sp>
-      <p:sp>
-        <p:nvSpPr>
-          <p:cNvPr id="57" name="Google Shape;57;g3f2dfdaf518_0_1:notes">
-            <a:extLst>
-              <a:ext uri="{FF2B5EF4-FFF2-40B4-BE49-F238E27FC236}">
-                <a16:creationId xmlns:a16="http://schemas.microsoft.com/office/drawing/2014/main" id="{605D3E22-BDC3-43B6-2849-F2D28AB0C3DD}"/>
-              </a:ext>
-            </a:extLst>
-          </p:cNvPr>
-          <p:cNvSpPr txBox="1">
-            <a:spLocks noGrp="1"/>
-          </p:cNvSpPr>
-          <p:nvPr>
-            <p:ph type="body" idx="1"/>
-          </p:nvPr>
-        </p:nvSpPr>
-        <p:spPr>
-          <a:xfrm>
-            <a:off x="685800" y="4343400"/>
-            <a:ext cx="5486400" cy="4114800"/>
-          </a:xfrm>
-          <a:prstGeom prst="rect">
-            <a:avLst/>
-          </a:prstGeom>
-        </p:spPr>
-        <p:txBody>
-          <a:bodyPr spcFirstLastPara="1" wrap="square" lIns="91425" tIns="91425" rIns="91425" bIns="91425" anchor="t" anchorCtr="0">
-            <a:noAutofit/>
-          </a:bodyPr>
-          <a:lstStyle/>
-          <a:p>
-            <a:pPr marL="0" lvl="0" indent="0" algn="l" rtl="0">
-              <a:spcBef>
-                <a:spcPts val="0"/>
-              </a:spcBef>
-              <a:spcAft>
-                <a:spcPts val="0"/>
-              </a:spcAft>
-              <a:buNone/>
-            </a:pPr>
-            <a:endParaRPr/>
-          </a:p>
-        </p:txBody>
-      </p:sp>
-    </p:spTree>
-    <p:extLst>
-      <p:ext uri="{BB962C8B-B14F-4D97-AF65-F5344CB8AC3E}">
-        <p14:creationId xmlns:p14="http://schemas.microsoft.com/office/powerpoint/2010/main" val="4245483543"/>
-      </p:ext>
-    </p:extLst>
   </p:cSld>
   <p:clrMapOvr>
     <a:masterClrMapping/>
@@ -6024,129 +5897,6 @@
           </a:prstGeom>
         </p:spPr>
       </p:pic>
-      <p:sp>
-        <p:nvSpPr>
-          <p:cNvPr id="4" name="TextBox 3"/>
-          <p:cNvSpPr txBox="1"/>
-          <p:nvPr/>
-        </p:nvSpPr>
-        <p:spPr>
-          <a:xfrm>
-            <a:off x="457200" y="182880"/>
-            <a:ext cx="8229600" cy="731520"/>
-          </a:xfrm>
-          <a:prstGeom prst="rect">
-            <a:avLst/>
-          </a:prstGeom>
-          <a:noFill/>
-        </p:spPr>
-        <p:txBody>
-          <a:bodyPr wrap="square" lIns="0" tIns="0">
-            <a:spAutoFit/>
-          </a:bodyPr>
-          <a:lstStyle/>
-          <a:p>
-            <a:pPr>
-              <a:defRPr sz="2100" b="1">
-                <a:solidFill>
-                  <a:srgbClr val="ED1D24"/>
-                </a:solidFill>
-                <a:latin typeface="Calibri"/>
-              </a:defRPr>
-            </a:pPr>
-            <a:r>
-              <a:t>Annexure 2: Inbound Customer Portal &amp; Choice Matrices</a:t>
-            </a:r>
-          </a:p>
-        </p:txBody>
-      </p:sp>
-      <p:sp>
-        <p:nvSpPr>
-          <p:cNvPr id="5" name="TextBox 4"/>
-          <p:cNvSpPr txBox="1"/>
-          <p:nvPr/>
-        </p:nvSpPr>
-        <p:spPr>
-          <a:xfrm>
-            <a:off x="457200" y="1005840"/>
-            <a:ext cx="3840480" cy="3657600"/>
-          </a:xfrm>
-          <a:prstGeom prst="rect">
-            <a:avLst/>
-          </a:prstGeom>
-          <a:noFill/>
-        </p:spPr>
-        <p:txBody>
-          <a:bodyPr wrap="square" lIns="0" tIns="0">
-            <a:spAutoFit/>
-          </a:bodyPr>
-          <a:lstStyle/>
-          <a:p>
-            <a:pPr>
-              <a:spcAft>
-                <a:spcPts val="800"/>
-              </a:spcAft>
-              <a:defRPr sz="1300" b="1">
-                <a:solidFill>
-                  <a:srgbClr val="0F121C"/>
-                </a:solidFill>
-                <a:latin typeface="Calibri"/>
-              </a:defRPr>
-            </a:pPr>
-            <a:r>
-              <a:t>Digitizing the Onboarding Funnel</a:t>
-            </a:r>
-          </a:p>
-          <a:p>
-            <a:pPr>
-              <a:spcAft>
-                <a:spcPts val="600"/>
-              </a:spcAft>
-              <a:defRPr sz="950" b="0">
-                <a:solidFill>
-                  <a:srgbClr val="212121"/>
-                </a:solidFill>
-                <a:latin typeface="Arial"/>
-              </a:defRPr>
-            </a:pPr>
-            <a:r>
-              <a:t>• Website Re-architecting: Designed a premium tab-based structure instead of long scroll sheets, streamlining categories for different household priorities.</a:t>
-            </a:r>
-          </a:p>
-          <a:p>
-            <a:pPr>
-              <a:spcAft>
-                <a:spcPts val="600"/>
-              </a:spcAft>
-              <a:defRPr sz="950" b="0">
-                <a:solidFill>
-                  <a:srgbClr val="212121"/>
-                </a:solidFill>
-                <a:latin typeface="Arial"/>
-              </a:defRPr>
-            </a:pPr>
-            <a:r>
-              <a:t>• AirBot Integration: AirBot acts as a frictionless digital concierge. It replaces standard sales pitch dialogue with multi-select service checklists and contextual profiling.</a:t>
-            </a:r>
-          </a:p>
-          <a:p>
-            <a:pPr>
-              <a:spcAft>
-                <a:spcPts val="600"/>
-              </a:spcAft>
-              <a:defRPr sz="950" b="0">
-                <a:solidFill>
-                  <a:srgbClr val="212121"/>
-                </a:solidFill>
-                <a:latin typeface="Arial"/>
-              </a:defRPr>
-            </a:pPr>
-            <a:r>
-              <a:t>• Autopay &amp; Coin Loops: The online checkout dynamically demonstrates monthly savings (₹50 discount) and Thanks Coins loyalty accumulation to increase signup rates.</a:t>
-            </a:r>
-          </a:p>
-        </p:txBody>
-      </p:sp>
       <p:pic>
         <p:nvPicPr>
           <p:cNvPr id="6" name="Picture 5" descr="image.jpg"/>
@@ -6230,129 +5980,6 @@
           </a:prstGeom>
         </p:spPr>
       </p:pic>
-      <p:sp>
-        <p:nvSpPr>
-          <p:cNvPr id="4" name="TextBox 3"/>
-          <p:cNvSpPr txBox="1"/>
-          <p:nvPr/>
-        </p:nvSpPr>
-        <p:spPr>
-          <a:xfrm>
-            <a:off x="457200" y="182880"/>
-            <a:ext cx="8229600" cy="731520"/>
-          </a:xfrm>
-          <a:prstGeom prst="rect">
-            <a:avLst/>
-          </a:prstGeom>
-          <a:noFill/>
-        </p:spPr>
-        <p:txBody>
-          <a:bodyPr wrap="square" lIns="0" tIns="0">
-            <a:spAutoFit/>
-          </a:bodyPr>
-          <a:lstStyle/>
-          <a:p>
-            <a:pPr>
-              <a:defRPr sz="2100" b="1">
-                <a:solidFill>
-                  <a:srgbClr val="ED1D24"/>
-                </a:solidFill>
-                <a:latin typeface="Calibri"/>
-              </a:defRPr>
-            </a:pPr>
-            <a:r>
-              <a:t>Annexure 3: Data-Driven Target Cohorts &amp; Economics</a:t>
-            </a:r>
-          </a:p>
-        </p:txBody>
-      </p:sp>
-      <p:sp>
-        <p:nvSpPr>
-          <p:cNvPr id="5" name="TextBox 4"/>
-          <p:cNvSpPr txBox="1"/>
-          <p:nvPr/>
-        </p:nvSpPr>
-        <p:spPr>
-          <a:xfrm>
-            <a:off x="457200" y="1005840"/>
-            <a:ext cx="8229600" cy="3657600"/>
-          </a:xfrm>
-          <a:prstGeom prst="rect">
-            <a:avLst/>
-          </a:prstGeom>
-          <a:noFill/>
-        </p:spPr>
-        <p:txBody>
-          <a:bodyPr wrap="square" lIns="0" tIns="0">
-            <a:spAutoFit/>
-          </a:bodyPr>
-          <a:lstStyle/>
-          <a:p>
-            <a:pPr>
-              <a:spcAft>
-                <a:spcPts val="800"/>
-              </a:spcAft>
-              <a:defRPr sz="1300" b="1">
-                <a:solidFill>
-                  <a:srgbClr val="0F121C"/>
-                </a:solidFill>
-                <a:latin typeface="Calibri"/>
-              </a:defRPr>
-            </a:pPr>
-            <a:r>
-              <a:t>AI-Targeted Cross-Sell Opportunities (Exhibits 4 &amp; 5)</a:t>
-            </a:r>
-          </a:p>
-          <a:p>
-            <a:pPr>
-              <a:spcAft>
-                <a:spcPts val="600"/>
-              </a:spcAft>
-              <a:defRPr sz="950" b="0">
-                <a:solidFill>
-                  <a:srgbClr val="212121"/>
-                </a:solidFill>
-                <a:latin typeface="Arial"/>
-              </a:defRPr>
-            </a:pPr>
-            <a:r>
-              <a:t>• Cohort A: High-Intent Overlaps (2.5M Users): Target the 2.5 million households subscribing to both Broadband and DTH. Since they are already double-billed, they represent low-hanging fruit for the 'Connect' or 'Family Secure' bundles.</a:t>
-            </a:r>
-          </a:p>
-          <a:p>
-            <a:pPr>
-              <a:spcAft>
-                <a:spcPts val="600"/>
-              </a:spcAft>
-              <a:defRPr sz="950" b="0">
-                <a:solidFill>
-                  <a:srgbClr val="212121"/>
-                </a:solidFill>
-                <a:latin typeface="Arial"/>
-              </a:defRPr>
-            </a:pPr>
-            <a:r>
-              <a:t>• Cohort B: DTH-Only Accounts (16M Users): DTH is expected to decline due to streaming (Exhibit 2). Transitioning these 16 million siloed accounts into converged Fiber+SIM+TV bundles saves them money while preventing DTH cord-cutting.</a:t>
-            </a:r>
-          </a:p>
-          <a:p>
-            <a:pPr>
-              <a:spcAft>
-                <a:spcPts val="600"/>
-              </a:spcAft>
-              <a:defRPr sz="950" b="0">
-                <a:solidFill>
-                  <a:srgbClr val="212121"/>
-                </a:solidFill>
-                <a:latin typeface="Arial"/>
-              </a:defRPr>
-            </a:pPr>
-            <a:r>
-              <a:t>• Channel Optimization: Digital channel CAC is 50% lower than direct sales (Broadband: ₹220 vs ₹450), but direct sales secure higher Month-4 retention. We route online AirBot leads directly to concierge field technicians to optimize conversion.</a:t>
-            </a:r>
-          </a:p>
-        </p:txBody>
-      </p:sp>
     </p:spTree>
   </p:cSld>
   <p:clrMapOvr>
@@ -6412,161 +6039,239 @@
           </a:prstGeom>
         </p:spPr>
       </p:pic>
-      <p:sp>
-        <p:nvSpPr>
-          <p:cNvPr id="4" name="TextBox 3"/>
-          <p:cNvSpPr txBox="1"/>
+      <p:pic>
+        <p:nvPicPr>
+          <p:cNvPr id="7" name="Picture 6" descr="image.png"/>
+          <p:cNvPicPr>
+            <a:picLocks noChangeAspect="1"/>
+          </p:cNvPicPr>
           <p:nvPr/>
-        </p:nvSpPr>
+        </p:nvPicPr>
+        <p:blipFill>
+          <a:blip r:embed="rId3"/>
+          <a:stretch>
+            <a:fillRect/>
+          </a:stretch>
+        </p:blipFill>
         <p:spPr>
           <a:xfrm>
-            <a:off x="457200" y="182880"/>
-            <a:ext cx="8229600" cy="731520"/>
+            <a:off x="4389120" y="1005840"/>
+            <a:ext cx="1005840" cy="1097280"/>
           </a:xfrm>
           <a:prstGeom prst="rect">
             <a:avLst/>
           </a:prstGeom>
-          <a:noFill/>
+          <a:ln w="12700">
+            <a:solidFill>
+              <a:srgbClr val="E4E6EB"/>
+            </a:solidFill>
+          </a:ln>
         </p:spPr>
-        <p:txBody>
-          <a:bodyPr wrap="square" lIns="0" tIns="0">
-            <a:spAutoFit/>
-          </a:bodyPr>
-          <a:lstStyle/>
-          <a:p>
-            <a:pPr>
-              <a:defRPr sz="2100" b="1">
-                <a:solidFill>
-                  <a:srgbClr val="ED1D24"/>
-                </a:solidFill>
-                <a:latin typeface="Calibri"/>
-              </a:defRPr>
-            </a:pPr>
-            <a:r>
-              <a:t>Annexure 4: Bundle Pricing Model &amp; EBITDA Accretion</a:t>
-            </a:r>
-          </a:p>
-        </p:txBody>
-      </p:sp>
-      <p:sp>
-        <p:nvSpPr>
-          <p:cNvPr id="5" name="TextBox 4"/>
-          <p:cNvSpPr txBox="1"/>
+      </p:pic>
+      <p:pic>
+        <p:nvPicPr>
+          <p:cNvPr id="9" name="Picture 8" descr="image.png"/>
+          <p:cNvPicPr>
+            <a:picLocks noChangeAspect="1"/>
+          </p:cNvPicPr>
           <p:nvPr/>
-        </p:nvSpPr>
+        </p:nvPicPr>
+        <p:blipFill>
+          <a:blip r:embed="rId4"/>
+          <a:stretch>
+            <a:fillRect/>
+          </a:stretch>
+        </p:blipFill>
         <p:spPr>
           <a:xfrm>
-            <a:off x="457200" y="1005840"/>
-            <a:ext cx="8229600" cy="3657600"/>
+            <a:off x="4389120" y="2286000"/>
+            <a:ext cx="1828800" cy="1033271"/>
           </a:xfrm>
           <a:prstGeom prst="rect">
             <a:avLst/>
           </a:prstGeom>
-          <a:noFill/>
+          <a:ln w="12700">
+            <a:solidFill>
+              <a:srgbClr val="E4E6EB"/>
+            </a:solidFill>
+          </a:ln>
         </p:spPr>
+      </p:pic>
+      <p:pic>
+        <p:nvPicPr>
+          <p:cNvPr id="11" name="Picture 10" descr="image.png"/>
+          <p:cNvPicPr>
+            <a:picLocks noChangeAspect="1"/>
+          </p:cNvPicPr>
+          <p:nvPr/>
+        </p:nvPicPr>
+        <p:blipFill>
+          <a:blip r:embed="rId5"/>
+          <a:stretch>
+            <a:fillRect/>
+          </a:stretch>
+        </p:blipFill>
+        <p:spPr>
+          <a:xfrm>
+            <a:off x="4389120" y="3474720"/>
+            <a:ext cx="1828800" cy="1033271"/>
+          </a:xfrm>
+          <a:prstGeom prst="rect">
+            <a:avLst/>
+          </a:prstGeom>
+          <a:ln w="12700">
+            <a:solidFill>
+              <a:srgbClr val="E4E6EB"/>
+            </a:solidFill>
+          </a:ln>
+        </p:spPr>
+      </p:pic>
+    </p:spTree>
+  </p:cSld>
+  <p:clrMapOvr>
+    <a:masterClrMapping/>
+  </p:clrMapOvr>
+</p:sld>
+</file>
+
+<file path=ppt/slides/slide12.xml><?xml version="1.0" encoding="utf-8"?>
+<p:sld xmlns:a="http://schemas.openxmlformats.org/drawingml/2006/main" xmlns:p="http://schemas.openxmlformats.org/presentationml/2006/main" xmlns:r="http://schemas.openxmlformats.org/officeDocument/2006/relationships">
+  <p:cSld>
+    <p:spTree>
+      <p:nvGrpSpPr>
+        <p:cNvPr id="1" name=""/>
+        <p:cNvGrpSpPr/>
+        <p:nvPr/>
+      </p:nvGrpSpPr>
+      <p:grpSpPr/>
+      <p:sp>
+        <p:nvSpPr>
+          <p:cNvPr id="2" name="Title 1"/>
+          <p:cNvSpPr>
+            <a:spLocks noGrp="1"/>
+          </p:cNvSpPr>
+          <p:nvPr>
+            <p:ph type="title"/>
+          </p:nvPr>
+        </p:nvSpPr>
+        <p:spPr/>
         <p:txBody>
-          <a:bodyPr wrap="square" lIns="0" tIns="0">
-            <a:spAutoFit/>
-          </a:bodyPr>
+          <a:bodyPr/>
           <a:lstStyle/>
-          <a:p>
-            <a:pPr>
-              <a:spcAft>
-                <a:spcPts val="800"/>
-              </a:spcAft>
-              <a:defRPr sz="1300" b="1">
-                <a:solidFill>
-                  <a:srgbClr val="0F121C"/>
-                </a:solidFill>
-                <a:latin typeface="Calibri"/>
-              </a:defRPr>
-            </a:pPr>
-            <a:r>
-              <a:t>Converged Pricing Sheets &amp; EBITDA Margins (Exhibits 1 &amp; 2)</a:t>
-            </a:r>
-          </a:p>
-          <a:p>
-            <a:pPr>
-              <a:spcAft>
-                <a:spcPts val="600"/>
-              </a:spcAft>
-              <a:defRPr sz="950" b="0">
-                <a:solidFill>
-                  <a:srgbClr val="212121"/>
-                </a:solidFill>
-                <a:latin typeface="Arial"/>
-              </a:defRPr>
-            </a:pPr>
-            <a:r>
-              <a:t>• Individual vs. Bundle Price Matrix:</a:t>
-            </a:r>
-          </a:p>
-          <a:p>
-            <a:pPr>
-              <a:spcAft>
-                <a:spcPts val="600"/>
-              </a:spcAft>
-              <a:defRPr sz="950" b="0">
-                <a:solidFill>
-                  <a:srgbClr val="212121"/>
-                </a:solidFill>
-                <a:latin typeface="Arial"/>
-              </a:defRPr>
-            </a:pPr>
-            <a:r>
-              <a:t>   - Standalone Sum: Broadband (₹599) + 2 SIMs (₹700) + Xstream Box (₹250) + Google One (₹209) + Xsafe CCTV (₹150) + Bank (₹99) = ₹2,006/mo.</a:t>
-            </a:r>
-          </a:p>
-          <a:p>
-            <a:pPr>
-              <a:spcAft>
-                <a:spcPts val="600"/>
-              </a:spcAft>
-              <a:defRPr sz="950" b="0">
-                <a:solidFill>
-                  <a:srgbClr val="212121"/>
-                </a:solidFill>
-                <a:latin typeface="Arial"/>
-              </a:defRPr>
-            </a:pPr>
-            <a:r>
-              <a:t>   - Consolidated Family Secure: ₹1,499/mo (Saves ₹507/mo or 25% discount). Promoted at ₹999/mo for the first 3 months to destroy switching inertia.</a:t>
-            </a:r>
-          </a:p>
-          <a:p>
-            <a:pPr>
-              <a:spcAft>
-                <a:spcPts val="600"/>
-              </a:spcAft>
-              <a:defRPr sz="950" b="0">
-                <a:solidFill>
-                  <a:srgbClr val="212121"/>
-                </a:solidFill>
-                <a:latin typeface="Arial"/>
-              </a:defRPr>
-            </a:pPr>
-            <a:r>
-              <a:t>• Margin Protection: Home Surveillance holds the highest EBITDA margin at 35% (Exhibit 1) and is growing at 35.7% CAGR (Exhibit 2). By bundling Xsafe cameras into Family Secure and Infinite tiers, we offset lower TV margins (12% EBITDA) and drive net margin expansion.</a:t>
-            </a:r>
-          </a:p>
-          <a:p>
-            <a:pPr>
-              <a:spcAft>
-                <a:spcPts val="600"/>
-              </a:spcAft>
-              <a:defRPr sz="950" b="0">
-                <a:solidFill>
-                  <a:srgbClr val="212121"/>
-                </a:solidFill>
-                <a:latin typeface="Arial"/>
-              </a:defRPr>
-            </a:pPr>
-            <a:r>
-              <a:t>• Churn Leverage: Reducing household churn from 22% down to 5% lifts customer lifetime value (LTV) by over 400%, easily amortizing the initial ₹999/mo introductory launch promo cost.</a:t>
-            </a:r>
-          </a:p>
+          <a:p/>
         </p:txBody>
       </p:sp>
+      <p:pic>
+        <p:nvPicPr>
+          <p:cNvPr id="3" name="Picture 2" descr="image.jpg"/>
+          <p:cNvPicPr>
+            <a:picLocks noChangeAspect="1"/>
+          </p:cNvPicPr>
+          <p:nvPr/>
+        </p:nvPicPr>
+        <p:blipFill>
+          <a:blip r:embed="rId2"/>
+          <a:stretch>
+            <a:fillRect/>
+          </a:stretch>
+        </p:blipFill>
+        <p:spPr>
+          <a:xfrm>
+            <a:off x="1" y="0"/>
+            <a:ext cx="9144000" cy="5143500"/>
+          </a:xfrm>
+          <a:prstGeom prst="rect">
+            <a:avLst/>
+          </a:prstGeom>
+        </p:spPr>
+      </p:pic>
+      <p:pic>
+        <p:nvPicPr>
+          <p:cNvPr id="7" name="Picture 6" descr="image.png"/>
+          <p:cNvPicPr>
+            <a:picLocks noChangeAspect="1"/>
+          </p:cNvPicPr>
+          <p:nvPr/>
+        </p:nvPicPr>
+        <p:blipFill>
+          <a:blip r:embed="rId3"/>
+          <a:stretch>
+            <a:fillRect/>
+          </a:stretch>
+        </p:blipFill>
+        <p:spPr>
+          <a:xfrm>
+            <a:off x="4389120" y="1005840"/>
+            <a:ext cx="1005840" cy="1097280"/>
+          </a:xfrm>
+          <a:prstGeom prst="rect">
+            <a:avLst/>
+          </a:prstGeom>
+          <a:ln w="12700">
+            <a:solidFill>
+              <a:srgbClr val="E4E6EB"/>
+            </a:solidFill>
+          </a:ln>
+        </p:spPr>
+      </p:pic>
+      <p:pic>
+        <p:nvPicPr>
+          <p:cNvPr id="9" name="Picture 8" descr="image.png"/>
+          <p:cNvPicPr>
+            <a:picLocks noChangeAspect="1"/>
+          </p:cNvPicPr>
+          <p:nvPr/>
+        </p:nvPicPr>
+        <p:blipFill>
+          <a:blip r:embed="rId4"/>
+          <a:stretch>
+            <a:fillRect/>
+          </a:stretch>
+        </p:blipFill>
+        <p:spPr>
+          <a:xfrm>
+            <a:off x="4389120" y="2286000"/>
+            <a:ext cx="1828800" cy="1033271"/>
+          </a:xfrm>
+          <a:prstGeom prst="rect">
+            <a:avLst/>
+          </a:prstGeom>
+          <a:ln w="12700">
+            <a:solidFill>
+              <a:srgbClr val="E4E6EB"/>
+            </a:solidFill>
+          </a:ln>
+        </p:spPr>
+      </p:pic>
+      <p:pic>
+        <p:nvPicPr>
+          <p:cNvPr id="11" name="Picture 10" descr="image.png"/>
+          <p:cNvPicPr>
+            <a:picLocks noChangeAspect="1"/>
+          </p:cNvPicPr>
+          <p:nvPr/>
+        </p:nvPicPr>
+        <p:blipFill>
+          <a:blip r:embed="rId5"/>
+          <a:stretch>
+            <a:fillRect/>
+          </a:stretch>
+        </p:blipFill>
+        <p:spPr>
+          <a:xfrm>
+            <a:off x="4389120" y="3474720"/>
+            <a:ext cx="1828800" cy="1033271"/>
+          </a:xfrm>
+          <a:prstGeom prst="rect">
+            <a:avLst/>
+          </a:prstGeom>
+          <a:ln w="12700">
+            <a:solidFill>
+              <a:srgbClr val="E4E6EB"/>
+            </a:solidFill>
+          </a:ln>
+        </p:spPr>
+      </p:pic>
     </p:spTree>
   </p:cSld>
   <p:clrMapOvr>
@@ -6658,8 +6363,8 @@
       </p:sp>
       <p:sp>
         <p:nvSpPr>
-          <p:cNvPr id="61" name="TextBox 60"/>
-          <p:cNvSpPr txBox="1"/>
+          <p:cNvPr id="61" name="Rounded Rectangle 60"/>
+          <p:cNvSpPr/>
           <p:nvPr/>
         </p:nvSpPr>
         <p:spPr>
@@ -6667,20 +6372,39 @@
             <a:off x="457200" y="1005840"/>
             <a:ext cx="2468880" cy="3657600"/>
           </a:xfrm>
-          <a:prstGeom prst="rect">
+          <a:prstGeom prst="roundRect">
             <a:avLst/>
           </a:prstGeom>
-          <a:noFill/>
+          <a:solidFill>
+            <a:srgbClr val="F8F9FA"/>
+          </a:solidFill>
+          <a:ln w="12700">
+            <a:solidFill>
+              <a:srgbClr val="E4E6EB"/>
+            </a:solidFill>
+          </a:ln>
         </p:spPr>
+        <p:style>
+          <a:lnRef idx="1">
+            <a:schemeClr val="accent1"/>
+          </a:lnRef>
+          <a:fillRef idx="3">
+            <a:schemeClr val="accent1"/>
+          </a:fillRef>
+          <a:effectRef idx="2">
+            <a:schemeClr val="accent1"/>
+          </a:effectRef>
+          <a:fontRef idx="minor">
+            <a:schemeClr val="lt1"/>
+          </a:fontRef>
+        </p:style>
         <p:txBody>
-          <a:bodyPr wrap="square" lIns="0" tIns="0">
-            <a:spAutoFit/>
-          </a:bodyPr>
+          <a:bodyPr rtlCol="0" anchor="t" wrap="square" lIns="137160" rIns="137160" tIns="164592" bIns="137160"/>
           <a:lstStyle/>
           <a:p>
-            <a:pPr>
-              <a:spcAft>
-                <a:spcPts val="800"/>
+            <a:pPr algn="ctr">
+              <a:spcAft>
+                <a:spcPts val="400"/>
               </a:spcAft>
               <a:defRPr sz="1300" b="1">
                 <a:solidFill>
@@ -6695,10 +6419,39 @@
           </a:p>
           <a:p>
             <a:pPr>
-              <a:spcAft>
-                <a:spcPts val="600"/>
-              </a:spcAft>
-              <a:defRPr sz="950" b="0">
+              <a:defRPr sz="3200" b="1">
+                <a:solidFill>
+                  <a:srgbClr val="ED1D24"/>
+                </a:solidFill>
+                <a:latin typeface="Calibri"/>
+              </a:defRPr>
+            </a:pPr>
+            <a:r>
+              <a:t>₹18,000</a:t>
+            </a:r>
+          </a:p>
+          <a:p>
+            <a:pPr>
+              <a:spcAft>
+                <a:spcPts val="800"/>
+              </a:spcAft>
+              <a:defRPr sz="850" b="1">
+                <a:solidFill>
+                  <a:srgbClr val="3498DB"/>
+                </a:solidFill>
+                <a:latin typeface="Arial"/>
+              </a:defRPr>
+            </a:pPr>
+            <a:r>
+              <a:t>Annual Wallet Opportunity per Home</a:t>
+            </a:r>
+          </a:p>
+          <a:p>
+            <a:pPr>
+              <a:spcAft>
+                <a:spcPts val="400"/>
+              </a:spcAft>
+              <a:defRPr sz="850" b="0">
                 <a:solidFill>
                   <a:srgbClr val="212121"/>
                 </a:solidFill>
@@ -6706,15 +6459,15 @@
               </a:defRPr>
             </a:pPr>
             <a:r>
-              <a:t>• Wallet Gaps: Connectivity accounts for 35% of household spend, but adjacent services like Entertainment (12%) and Home Security (2%) represent massive white spaces (Exhibit 3).</a:t>
+              <a:t>• Value White Spaces: Connectivity accounts for 35% of household spend, but adjacent services like Entertainment (12%) and Security (2%) represent massive white spaces (Exhibit 3).</a:t>
             </a:r>
           </a:p>
           <a:p>
             <a:pPr>
               <a:spcAft>
-                <a:spcPts val="600"/>
-              </a:spcAft>
-              <a:defRPr sz="950" b="0">
+                <a:spcPts val="400"/>
+              </a:spcAft>
+              <a:defRPr sz="850" b="0">
                 <a:solidFill>
                   <a:srgbClr val="212121"/>
                 </a:solidFill>
@@ -6722,15 +6475,15 @@
               </a:defRPr>
             </a:pPr>
             <a:r>
-              <a:t>• Bundling Retention: Moving a customer from 1 product to 3+ services drops annual churn from 22% to 5% while increasing annual revenue from ₹5,500 to ₹18,000 (Exhibit 4).</a:t>
+              <a:t>• Churn Moat: Moving a customer from 1 product to 3+ services drops annual churn from 22% to 5% (Exhibit 4).</a:t>
             </a:r>
           </a:p>
           <a:p>
             <a:pPr>
               <a:spcAft>
-                <a:spcPts val="600"/>
-              </a:spcAft>
-              <a:defRPr sz="950" b="0">
+                <a:spcPts val="400"/>
+              </a:spcAft>
+              <a:defRPr sz="850" b="0">
                 <a:solidFill>
                   <a:srgbClr val="212121"/>
                 </a:solidFill>
@@ -6738,15 +6491,58 @@
               </a:defRPr>
             </a:pPr>
             <a:r>
-              <a:t>• Postpaid Economics: Postpaid SIMs deliver ₹100 higher ARPU and 50% stronger customer stickiness than prepaid, yet organizational silos block seamless customer migrations.</a:t>
+              <a:t>• Postpaid Lift: Postpaid SIMs deliver ₹100 higher ARPU and 50% stronger customer stickiness than prepaid, yet silos block migrations.</a:t>
             </a:r>
           </a:p>
         </p:txBody>
       </p:sp>
       <p:sp>
         <p:nvSpPr>
-          <p:cNvPr id="62" name="TextBox 61"/>
-          <p:cNvSpPr txBox="1"/>
+          <p:cNvPr id="62" name="Rectangle 61"/>
+          <p:cNvSpPr/>
+          <p:nvPr/>
+        </p:nvSpPr>
+        <p:spPr>
+          <a:xfrm>
+            <a:off x="502920" y="1005840"/>
+            <a:ext cx="2377440" cy="73152"/>
+          </a:xfrm>
+          <a:prstGeom prst="rect">
+            <a:avLst/>
+          </a:prstGeom>
+          <a:solidFill>
+            <a:srgbClr val="ED1D24"/>
+          </a:solidFill>
+          <a:ln>
+            <a:noFill/>
+          </a:ln>
+        </p:spPr>
+        <p:style>
+          <a:lnRef idx="1">
+            <a:schemeClr val="accent1"/>
+          </a:lnRef>
+          <a:fillRef idx="3">
+            <a:schemeClr val="accent1"/>
+          </a:fillRef>
+          <a:effectRef idx="2">
+            <a:schemeClr val="accent1"/>
+          </a:effectRef>
+          <a:fontRef idx="minor">
+            <a:schemeClr val="lt1"/>
+          </a:fontRef>
+        </p:style>
+        <p:txBody>
+          <a:bodyPr rtlCol="0" anchor="ctr"/>
+          <a:lstStyle/>
+          <a:p>
+            <a:pPr algn="ctr"/>
+          </a:p>
+        </p:txBody>
+      </p:sp>
+      <p:sp>
+        <p:nvSpPr>
+          <p:cNvPr id="63" name="Rounded Rectangle 62"/>
+          <p:cNvSpPr/>
           <p:nvPr/>
         </p:nvSpPr>
         <p:spPr>
@@ -6754,20 +6550,39 @@
             <a:off x="3291840" y="1005840"/>
             <a:ext cx="2468880" cy="3657600"/>
           </a:xfrm>
-          <a:prstGeom prst="rect">
+          <a:prstGeom prst="roundRect">
             <a:avLst/>
           </a:prstGeom>
-          <a:noFill/>
+          <a:solidFill>
+            <a:srgbClr val="F8F9FA"/>
+          </a:solidFill>
+          <a:ln w="12700">
+            <a:solidFill>
+              <a:srgbClr val="E4E6EB"/>
+            </a:solidFill>
+          </a:ln>
         </p:spPr>
+        <p:style>
+          <a:lnRef idx="1">
+            <a:schemeClr val="accent1"/>
+          </a:lnRef>
+          <a:fillRef idx="3">
+            <a:schemeClr val="accent1"/>
+          </a:fillRef>
+          <a:effectRef idx="2">
+            <a:schemeClr val="accent1"/>
+          </a:effectRef>
+          <a:fontRef idx="minor">
+            <a:schemeClr val="lt1"/>
+          </a:fontRef>
+        </p:style>
         <p:txBody>
-          <a:bodyPr wrap="square" lIns="0" tIns="0">
-            <a:spAutoFit/>
-          </a:bodyPr>
+          <a:bodyPr rtlCol="0" anchor="t" wrap="square" lIns="137160" rIns="137160" tIns="164592" bIns="137160"/>
           <a:lstStyle/>
           <a:p>
-            <a:pPr>
-              <a:spcAft>
-                <a:spcPts val="800"/>
+            <a:pPr algn="ctr">
+              <a:spcAft>
+                <a:spcPts val="400"/>
               </a:spcAft>
               <a:defRPr sz="1300" b="1">
                 <a:solidFill>
@@ -6782,10 +6597,39 @@
           </a:p>
           <a:p>
             <a:pPr>
-              <a:spcAft>
-                <a:spcPts val="600"/>
-              </a:spcAft>
-              <a:defRPr sz="950" b="0">
+              <a:defRPr sz="3200" b="1">
+                <a:solidFill>
+                  <a:srgbClr val="0F121C"/>
+                </a:solidFill>
+                <a:latin typeface="Calibri"/>
+              </a:defRPr>
+            </a:pPr>
+            <a:r>
+              <a:t>60%+</a:t>
+            </a:r>
+          </a:p>
+          <a:p>
+            <a:pPr>
+              <a:spcAft>
+                <a:spcPts val="800"/>
+              </a:spcAft>
+              <a:defRPr sz="850" b="1">
+                <a:solidFill>
+                  <a:srgbClr val="3498DB"/>
+                </a:solidFill>
+                <a:latin typeface="Arial"/>
+              </a:defRPr>
+            </a:pPr>
+            <a:r>
+              <a:t>Households Fear Single Point of Failure</a:t>
+            </a:r>
+          </a:p>
+          <a:p>
+            <a:pPr>
+              <a:spcAft>
+                <a:spcPts val="400"/>
+              </a:spcAft>
+              <a:defRPr sz="850" b="0">
                 <a:solidFill>
                   <a:srgbClr val="212121"/>
                 </a:solidFill>
@@ -6793,15 +6637,15 @@
               </a:defRPr>
             </a:pPr>
             <a:r>
-              <a:t>• Prepaid Saturation: Prepaid mobile markets are mature with high penetration and constrained pricing power. Future growth must rely on adjacencies.</a:t>
+              <a:t>• Prepaid Saturation: Prepaid mobile markets are mature with high penetration and constrained pricing power. Growth must rely on adjacencies.</a:t>
             </a:r>
           </a:p>
           <a:p>
             <a:pPr>
               <a:spcAft>
-                <a:spcPts val="600"/>
-              </a:spcAft>
-              <a:defRPr sz="950" b="0">
+                <a:spcPts val="400"/>
+              </a:spcAft>
+              <a:defRPr sz="850" b="0">
                 <a:solidFill>
                   <a:srgbClr val="212121"/>
                 </a:solidFill>
@@ -6809,15 +6653,15 @@
               </a:defRPr>
             </a:pPr>
             <a:r>
-              <a:t>• Competitive Grid: Regional broadband players are fragmented, and DTH television revenues are shrinking globally due to cord-cutting pressures (Exhibit 1 &amp; 2).</a:t>
+              <a:t>• Cord-Cutting: DTH television revenues are shrinking globally due to cord-cutting pressures (Exhibit 1 &amp; 2).</a:t>
             </a:r>
           </a:p>
           <a:p>
             <a:pPr>
               <a:spcAft>
-                <a:spcPts val="600"/>
-              </a:spcAft>
-              <a:defRPr sz="950" b="0">
+                <a:spcPts val="400"/>
+              </a:spcAft>
+              <a:defRPr sz="850" b="0">
                 <a:solidFill>
                   <a:srgbClr val="212121"/>
                 </a:solidFill>
@@ -6825,15 +6669,58 @@
               </a:defRPr>
             </a:pPr>
             <a:r>
-              <a:t>• Persona Triggers: High-value connected households value unified billing and reward points. Core motivators include automated convenience (Autopay) and brand security trust.</a:t>
+              <a:t>• Persona Triggers: High-value households value unified billing and reward points. Core motivators include automated convenience and brand security trust.</a:t>
             </a:r>
           </a:p>
         </p:txBody>
       </p:sp>
       <p:sp>
         <p:nvSpPr>
-          <p:cNvPr id="63" name="TextBox 62"/>
-          <p:cNvSpPr txBox="1"/>
+          <p:cNvPr id="64" name="Rectangle 63"/>
+          <p:cNvSpPr/>
+          <p:nvPr/>
+        </p:nvSpPr>
+        <p:spPr>
+          <a:xfrm>
+            <a:off x="3337560" y="1005840"/>
+            <a:ext cx="2377440" cy="73152"/>
+          </a:xfrm>
+          <a:prstGeom prst="rect">
+            <a:avLst/>
+          </a:prstGeom>
+          <a:solidFill>
+            <a:srgbClr val="0F121C"/>
+          </a:solidFill>
+          <a:ln>
+            <a:noFill/>
+          </a:ln>
+        </p:spPr>
+        <p:style>
+          <a:lnRef idx="1">
+            <a:schemeClr val="accent1"/>
+          </a:lnRef>
+          <a:fillRef idx="3">
+            <a:schemeClr val="accent1"/>
+          </a:fillRef>
+          <a:effectRef idx="2">
+            <a:schemeClr val="accent1"/>
+          </a:effectRef>
+          <a:fontRef idx="minor">
+            <a:schemeClr val="lt1"/>
+          </a:fontRef>
+        </p:style>
+        <p:txBody>
+          <a:bodyPr rtlCol="0" anchor="ctr"/>
+          <a:lstStyle/>
+          <a:p>
+            <a:pPr algn="ctr"/>
+          </a:p>
+        </p:txBody>
+      </p:sp>
+      <p:sp>
+        <p:nvSpPr>
+          <p:cNvPr id="65" name="Rounded Rectangle 64"/>
+          <p:cNvSpPr/>
           <p:nvPr/>
         </p:nvSpPr>
         <p:spPr>
@@ -6841,20 +6728,39 @@
             <a:off x="6126480" y="1005840"/>
             <a:ext cx="2468880" cy="3657600"/>
           </a:xfrm>
-          <a:prstGeom prst="rect">
+          <a:prstGeom prst="roundRect">
             <a:avLst/>
           </a:prstGeom>
-          <a:noFill/>
+          <a:solidFill>
+            <a:srgbClr val="F8F9FA"/>
+          </a:solidFill>
+          <a:ln w="12700">
+            <a:solidFill>
+              <a:srgbClr val="E4E6EB"/>
+            </a:solidFill>
+          </a:ln>
         </p:spPr>
+        <p:style>
+          <a:lnRef idx="1">
+            <a:schemeClr val="accent1"/>
+          </a:lnRef>
+          <a:fillRef idx="3">
+            <a:schemeClr val="accent1"/>
+          </a:fillRef>
+          <a:effectRef idx="2">
+            <a:schemeClr val="accent1"/>
+          </a:effectRef>
+          <a:fontRef idx="minor">
+            <a:schemeClr val="lt1"/>
+          </a:fontRef>
+        </p:style>
         <p:txBody>
-          <a:bodyPr wrap="square" lIns="0" tIns="0">
-            <a:spAutoFit/>
-          </a:bodyPr>
+          <a:bodyPr rtlCol="0" anchor="t" wrap="square" lIns="137160" rIns="137160" tIns="164592" bIns="137160"/>
           <a:lstStyle/>
           <a:p>
-            <a:pPr>
-              <a:spcAft>
-                <a:spcPts val="800"/>
+            <a:pPr algn="ctr">
+              <a:spcAft>
+                <a:spcPts val="400"/>
               </a:spcAft>
               <a:defRPr sz="1300" b="1">
                 <a:solidFill>
@@ -6869,10 +6775,39 @@
           </a:p>
           <a:p>
             <a:pPr>
-              <a:spcAft>
-                <a:spcPts val="600"/>
-              </a:spcAft>
-              <a:defRPr sz="950" b="0">
+              <a:defRPr sz="3200" b="1">
+                <a:solidFill>
+                  <a:srgbClr val="3498DB"/>
+                </a:solidFill>
+                <a:latin typeface="Calibri"/>
+              </a:defRPr>
+            </a:pPr>
+            <a:r>
+              <a:t>12%</a:t>
+            </a:r>
+          </a:p>
+          <a:p>
+            <a:pPr>
+              <a:spcAft>
+                <a:spcPts val="800"/>
+              </a:spcAft>
+              <a:defRPr sz="850" b="1">
+                <a:solidFill>
+                  <a:srgbClr val="3498DB"/>
+                </a:solidFill>
+                <a:latin typeface="Arial"/>
+              </a:defRPr>
+            </a:pPr>
+            <a:r>
+              <a:t>Lowest Month-4 Customer Decay</a:t>
+            </a:r>
+          </a:p>
+          <a:p>
+            <a:pPr>
+              <a:spcAft>
+                <a:spcPts val="400"/>
+              </a:spcAft>
+              <a:defRPr sz="850" b="0">
                 <a:solidFill>
                   <a:srgbClr val="212121"/>
                 </a:solidFill>
@@ -6880,15 +6815,15 @@
               </a:defRPr>
             </a:pPr>
             <a:r>
-              <a:t>• Single Point of Failure: 60%+ of households fear putting mobile and fiber under one operator due to worry over complete connectivity blackout during fiber cuts.</a:t>
+              <a:t>• Infrastructure Dread: Households fear putting mobile and fiber under one operator due to worry over complete connectivity blackout during fiber cuts.</a:t>
             </a:r>
           </a:p>
           <a:p>
             <a:pPr>
               <a:spcAft>
-                <a:spcPts val="600"/>
-              </a:spcAft>
-              <a:defRPr sz="950" b="0">
+                <a:spcPts val="400"/>
+              </a:spcAft>
+              <a:defRPr sz="850" b="0">
                 <a:solidFill>
                   <a:srgbClr val="212121"/>
                 </a:solidFill>
@@ -6896,15 +6831,15 @@
               </a:defRPr>
             </a:pPr>
             <a:r>
-              <a:t>• Migration Complexity: Customers dread porting numbers and coordinating multiple technician visits for routers, TV boxes, and cameras.</a:t>
+              <a:t>• Setup Friction: Customers dread porting numbers and coordinating multiple technician visits.</a:t>
             </a:r>
           </a:p>
           <a:p>
             <a:pPr>
               <a:spcAft>
-                <a:spcPts val="600"/>
-              </a:spcAft>
-              <a:defRPr sz="950" b="0">
+                <a:spcPts val="400"/>
+              </a:spcAft>
+              <a:defRPr sz="850" b="0">
                 <a:solidFill>
                   <a:srgbClr val="212121"/>
                 </a:solidFill>
@@ -6912,371 +6847,55 @@
               </a:defRPr>
             </a:pPr>
             <a:r>
-              <a:t>• Product Silos: Sales and field forces work in independent silos, missing cross-sell during low-decay, in-home technician visits.</a:t>
+              <a:t>• Channel Silos: Sales and field forces work in independent silos, missing cross-sell during low-decay in-home technician visits.</a:t>
             </a:r>
           </a:p>
         </p:txBody>
       </p:sp>
-    </p:spTree>
-  </p:cSld>
-  <p:clrMapOvr>
-    <a:masterClrMapping/>
-  </p:clrMapOvr>
-</p:sld>
-</file>
-
-<file path=ppt/slides/slide3.xml><?xml version="1.0" encoding="utf-8"?>
-<p:sld xmlns:a="http://schemas.openxmlformats.org/drawingml/2006/main" xmlns:r="http://schemas.openxmlformats.org/officeDocument/2006/relationships" xmlns:p="http://schemas.openxmlformats.org/presentationml/2006/main">
-  <p:cSld>
-    <p:spTree>
-      <p:nvGrpSpPr>
-        <p:cNvPr id="1" name="Shape 58">
-          <a:extLst>
-            <a:ext uri="{FF2B5EF4-FFF2-40B4-BE49-F238E27FC236}">
-              <a16:creationId xmlns:a16="http://schemas.microsoft.com/office/drawing/2014/main" id="{26976F6B-61BC-F3CF-C2E0-C7C0296A4D56}"/>
-            </a:ext>
-          </a:extLst>
-        </p:cNvPr>
-        <p:cNvGrpSpPr/>
-        <p:nvPr/>
-      </p:nvGrpSpPr>
-      <p:grpSpPr>
-        <a:xfrm>
-          <a:off x="0" y="0"/>
-          <a:ext cx="0" cy="0"/>
-          <a:chOff x="0" y="0"/>
-          <a:chExt cx="0" cy="0"/>
-        </a:xfrm>
-      </p:grpSpPr>
-      <p:pic>
-        <p:nvPicPr>
-          <p:cNvPr id="59" name="Google Shape;59;p14" title="Submission Template-02.jpg">
-            <a:extLst>
-              <a:ext uri="{FF2B5EF4-FFF2-40B4-BE49-F238E27FC236}">
-                <a16:creationId xmlns:a16="http://schemas.microsoft.com/office/drawing/2014/main" id="{BF979149-14EB-AA73-037B-56EF7FEC7567}"/>
-              </a:ext>
-            </a:extLst>
-          </p:cNvPr>
-          <p:cNvPicPr preferRelativeResize="0"/>
+      <p:sp>
+        <p:nvSpPr>
+          <p:cNvPr id="66" name="Rectangle 65"/>
+          <p:cNvSpPr/>
           <p:nvPr/>
-        </p:nvPicPr>
-        <p:blipFill>
-          <a:blip r:embed="rId3">
-            <a:alphaModFix/>
-          </a:blip>
-          <a:stretch>
-            <a:fillRect/>
-          </a:stretch>
-        </p:blipFill>
+        </p:nvSpPr>
         <p:spPr>
           <a:xfrm>
-            <a:off x="1" y="0"/>
-            <a:ext cx="9144000" cy="5143500"/>
+            <a:off x="6172200" y="1005840"/>
+            <a:ext cx="2377440" cy="73152"/>
           </a:xfrm>
           <a:prstGeom prst="rect">
             <a:avLst/>
           </a:prstGeom>
-          <a:noFill/>
+          <a:solidFill>
+            <a:srgbClr val="3498DB"/>
+          </a:solidFill>
           <a:ln>
             <a:noFill/>
           </a:ln>
         </p:spPr>
-      </p:pic>
-      <p:sp>
-        <p:nvSpPr>
-          <p:cNvPr id="60" name="TextBox 59">
-            <a:extLst>
-              <a:ext uri="{FF2B5EF4-FFF2-40B4-BE49-F238E27FC236}">
-                <a16:creationId xmlns:a16="http://schemas.microsoft.com/office/drawing/2014/main" id="{E75D3418-42E5-6285-F2F1-28AC5CF1E198}"/>
-              </a:ext>
-            </a:extLst>
-          </p:cNvPr>
-          <p:cNvSpPr txBox="1"/>
-          <p:nvPr/>
-        </p:nvSpPr>
-        <p:spPr>
-          <a:xfrm>
-            <a:off x="457200" y="388620"/>
-            <a:ext cx="8229600" cy="731520"/>
-          </a:xfrm>
-          <a:prstGeom prst="rect">
-            <a:avLst/>
-          </a:prstGeom>
-          <a:noFill/>
-        </p:spPr>
+        <p:style>
+          <a:lnRef idx="1">
+            <a:schemeClr val="accent1"/>
+          </a:lnRef>
+          <a:fillRef idx="3">
+            <a:schemeClr val="accent1"/>
+          </a:fillRef>
+          <a:effectRef idx="2">
+            <a:schemeClr val="accent1"/>
+          </a:effectRef>
+          <a:fontRef idx="minor">
+            <a:schemeClr val="lt1"/>
+          </a:fontRef>
+        </p:style>
         <p:txBody>
-          <a:bodyPr wrap="square" lIns="0" tIns="0">
-            <a:spAutoFit/>
-          </a:bodyPr>
+          <a:bodyPr rtlCol="0" anchor="ctr"/>
           <a:lstStyle/>
           <a:p>
-            <a:pPr>
-              <a:defRPr sz="2200" b="1">
-                <a:solidFill>
-                  <a:srgbClr val="ED1D24"/>
-                </a:solidFill>
-                <a:latin typeface="Arial"/>
-              </a:defRPr>
-            </a:pPr>
-            <a:r>
-              <a:t>Altura Home: Inbound Ecosystem &amp; AI-Enabled GTM</a:t>
-            </a:r>
-          </a:p>
-        </p:txBody>
-      </p:sp>
-      <p:sp>
-        <p:nvSpPr>
-          <p:cNvPr id="61" name="TextBox 60">
-            <a:extLst>
-              <a:ext uri="{FF2B5EF4-FFF2-40B4-BE49-F238E27FC236}">
-                <a16:creationId xmlns:a16="http://schemas.microsoft.com/office/drawing/2014/main" id="{F66AF7BD-8E64-0272-18D3-19EDAB3D8DA9}"/>
-              </a:ext>
-            </a:extLst>
-          </p:cNvPr>
-          <p:cNvSpPr txBox="1"/>
-          <p:nvPr/>
-        </p:nvSpPr>
-        <p:spPr>
-          <a:xfrm>
-            <a:off x="457200" y="1005840"/>
-            <a:ext cx="8229600" cy="1188720"/>
-          </a:xfrm>
-          <a:prstGeom prst="rect">
-            <a:avLst/>
-          </a:prstGeom>
-          <a:noFill/>
-        </p:spPr>
-        <p:txBody>
-          <a:bodyPr wrap="square" lIns="0" tIns="0">
-            <a:spAutoFit/>
-          </a:bodyPr>
-          <a:lstStyle/>
-          <a:p>
-            <a:pPr>
-              <a:spcAft>
-                <a:spcPts val="400"/>
-              </a:spcAft>
-              <a:defRPr sz="1200" b="1">
-                <a:solidFill>
-                  <a:srgbClr val="0F121C"/>
-                </a:solidFill>
-                <a:latin typeface="Arial"/>
-              </a:defRPr>
-            </a:pPr>
-            <a:r>
-              <a:t>1. Inbound Web, AirBot Chatbot &amp; Unified Bundling</a:t>
-            </a:r>
-          </a:p>
-          <a:p>
-            <a:pPr>
-              <a:spcAft>
-                <a:spcPts val="300"/>
-              </a:spcAft>
-              <a:defRPr sz="900" b="0">
-                <a:solidFill>
-                  <a:srgbClr val="212121"/>
-                </a:solidFill>
-                <a:latin typeface="Calibri"/>
-              </a:defRPr>
-            </a:pPr>
-            <a:r>
-              <a:t>• 4 Converged Plans: Starter (₹499/mo, 1 SIM + Xstream Play), Connect (₹999/mo, 40M Fiber + TV), Family Secure (₹999 promo, 100M Fiber + 2 SIMs + CCTV), Infinite (₹2,999/mo, 1G Fiber + 4 SIMs + 3 Cams).</a:t>
-            </a:r>
-          </a:p>
-          <a:p>
-            <a:pPr>
-              <a:spcAft>
-                <a:spcPts val="300"/>
-              </a:spcAft>
-              <a:defRPr sz="900" b="0">
-                <a:solidFill>
-                  <a:srgbClr val="212121"/>
-                </a:solidFill>
-                <a:latin typeface="Calibri"/>
-              </a:defRPr>
-            </a:pPr>
-            <a:r>
-              <a:t>• AirBot Digital Concierge: Web interactive bot using multi-select questionnaire filtering to route users to optimal bundles and reduce conversion friction.</a:t>
-            </a:r>
-          </a:p>
-          <a:p>
-            <a:pPr>
-              <a:spcAft>
-                <a:spcPts val="300"/>
-              </a:spcAft>
-              <a:defRPr sz="900" b="0">
-                <a:solidFill>
-                  <a:srgbClr val="212121"/>
-                </a:solidFill>
-                <a:latin typeface="Calibri"/>
-              </a:defRPr>
-            </a:pPr>
-            <a:r>
-              <a:t>• Autopay &amp; Coins Incentives: Instant ₹50/mo bill discount and monthly Thanks Coins points to secure loyalty, automate renewals, and reduce admin overhead.</a:t>
-            </a:r>
-          </a:p>
-        </p:txBody>
-      </p:sp>
-      <p:sp>
-        <p:nvSpPr>
-          <p:cNvPr id="62" name="TextBox 61">
-            <a:extLst>
-              <a:ext uri="{FF2B5EF4-FFF2-40B4-BE49-F238E27FC236}">
-                <a16:creationId xmlns:a16="http://schemas.microsoft.com/office/drawing/2014/main" id="{1E4728D8-8C70-103B-3CC3-50762A38B1F2}"/>
-              </a:ext>
-            </a:extLst>
-          </p:cNvPr>
-          <p:cNvSpPr txBox="1"/>
-          <p:nvPr/>
-        </p:nvSpPr>
-        <p:spPr>
-          <a:xfrm>
-            <a:off x="457200" y="2286000"/>
-            <a:ext cx="8229600" cy="1188720"/>
-          </a:xfrm>
-          <a:prstGeom prst="rect">
-            <a:avLst/>
-          </a:prstGeom>
-          <a:noFill/>
-        </p:spPr>
-        <p:txBody>
-          <a:bodyPr wrap="square" lIns="0" tIns="0">
-            <a:spAutoFit/>
-          </a:bodyPr>
-          <a:lstStyle/>
-          <a:p>
-            <a:pPr>
-              <a:spcAft>
-                <a:spcPts val="400"/>
-              </a:spcAft>
-              <a:defRPr sz="1200" b="1">
-                <a:solidFill>
-                  <a:srgbClr val="0F121C"/>
-                </a:solidFill>
-                <a:latin typeface="Arial"/>
-              </a:defRPr>
-            </a:pPr>
-            <a:r>
-              <a:t>2. Operational Overhaul: Defeating SPOF &amp; Installation Friction</a:t>
-            </a:r>
-          </a:p>
-          <a:p>
-            <a:pPr>
-              <a:spcAft>
-                <a:spcPts val="300"/>
-              </a:spcAft>
-              <a:defRPr sz="900" b="0">
-                <a:solidFill>
-                  <a:srgbClr val="212121"/>
-                </a:solidFill>
-                <a:latin typeface="Calibri"/>
-              </a:defRPr>
-            </a:pPr>
-            <a:r>
-              <a:t>• Independent Network Failover: Countering the 'Single Point of Failure' fear by educating users that Fiber WiFi, Cellular Postpaid SIMs, and DTH satellite feeds run on physically separate grids. Xsafe cameras failover automatically to mobile hotspots during outages.</a:t>
-            </a:r>
-          </a:p>
-          <a:p>
-            <a:pPr>
-              <a:spcAft>
-                <a:spcPts val="300"/>
-              </a:spcAft>
-              <a:defRPr sz="900" b="0">
-                <a:solidFill>
-                  <a:srgbClr val="212121"/>
-                </a:solidFill>
-                <a:latin typeface="Calibri"/>
-              </a:defRPr>
-            </a:pPr>
-            <a:r>
-              <a:t>• Single-Visit Concierge Engineers: Eliminating installation dread by deploying a single engineering specialist who installs broadband fiber, activates TV boxes, mounts CCTV cameras, and ports family mobile numbers in a single visit.</a:t>
-            </a:r>
-          </a:p>
-        </p:txBody>
-      </p:sp>
-      <p:sp>
-        <p:nvSpPr>
-          <p:cNvPr id="63" name="TextBox 62">
-            <a:extLst>
-              <a:ext uri="{FF2B5EF4-FFF2-40B4-BE49-F238E27FC236}">
-                <a16:creationId xmlns:a16="http://schemas.microsoft.com/office/drawing/2014/main" id="{2D7E885B-553E-B240-24D7-F13E34D84DA2}"/>
-              </a:ext>
-            </a:extLst>
-          </p:cNvPr>
-          <p:cNvSpPr txBox="1"/>
-          <p:nvPr/>
-        </p:nvSpPr>
-        <p:spPr>
-          <a:xfrm>
-            <a:off x="457200" y="3566160"/>
-            <a:ext cx="8229600" cy="1188720"/>
-          </a:xfrm>
-          <a:prstGeom prst="rect">
-            <a:avLst/>
-          </a:prstGeom>
-          <a:noFill/>
-        </p:spPr>
-        <p:txBody>
-          <a:bodyPr wrap="square" lIns="0" tIns="0">
-            <a:spAutoFit/>
-          </a:bodyPr>
-          <a:lstStyle/>
-          <a:p>
-            <a:pPr>
-              <a:spcAft>
-                <a:spcPts val="400"/>
-              </a:spcAft>
-              <a:defRPr sz="1200" b="1">
-                <a:solidFill>
-                  <a:srgbClr val="0F121C"/>
-                </a:solidFill>
-                <a:latin typeface="Arial"/>
-              </a:defRPr>
-            </a:pPr>
-            <a:r>
-              <a:t>3. Outbound Target Cohorts &amp; Field Force AI Enablement</a:t>
-            </a:r>
-          </a:p>
-          <a:p>
-            <a:pPr>
-              <a:spcAft>
-                <a:spcPts val="300"/>
-              </a:spcAft>
-              <a:defRPr sz="900" b="0">
-                <a:solidFill>
-                  <a:srgbClr val="212121"/>
-                </a:solidFill>
-                <a:latin typeface="Calibri"/>
-              </a:defRPr>
-            </a:pPr>
-            <a:r>
-              <a:t>• AI Customer Targeting: Leverage customer overlap data (Exhibit 4) to automatically run SMS &amp; app bundle upgrade prompts for the 2.5M overlapping Broadband+DTH users and the 16M DTH-only accounts.</a:t>
-            </a:r>
-          </a:p>
-          <a:p>
-            <a:pPr>
-              <a:spcAft>
-                <a:spcPts val="300"/>
-              </a:spcAft>
-              <a:defRPr sz="900" b="0">
-                <a:solidFill>
-                  <a:srgbClr val="212121"/>
-                </a:solidFill>
-                <a:latin typeface="Calibri"/>
-              </a:defRPr>
-            </a:pPr>
-            <a:r>
-              <a:t>• Service Engineer Enablement: Equipping the field technician mobile app with a predictive recommendation engine, prompting them to pitch security cameras (Xsafe) during regular maintenance visits (capturing the 12% low decay rate).</a:t>
-            </a:r>
+            <a:pPr algn="ctr"/>
           </a:p>
         </p:txBody>
       </p:sp>
     </p:spTree>
-    <p:extLst>
-      <p:ext uri="{BB962C8B-B14F-4D97-AF65-F5344CB8AC3E}">
-        <p14:creationId xmlns:p14="http://schemas.microsoft.com/office/powerpoint/2010/main" val="355609039"/>
-      </p:ext>
-    </p:extLst>
   </p:cSld>
   <p:clrMapOvr>
     <a:masterClrMapping/>
@@ -7576,138 +7195,6 @@
           </a:prstGeom>
         </p:spPr>
       </p:pic>
-      <p:sp>
-        <p:nvSpPr>
-          <p:cNvPr id="4" name="TextBox 3"/>
-          <p:cNvSpPr txBox="1"/>
-          <p:nvPr/>
-        </p:nvSpPr>
-        <p:spPr>
-          <a:xfrm>
-            <a:off x="457200" y="535971"/>
-            <a:ext cx="8229600" cy="731520"/>
-          </a:xfrm>
-          <a:prstGeom prst="rect">
-            <a:avLst/>
-          </a:prstGeom>
-          <a:noFill/>
-        </p:spPr>
-        <p:txBody>
-          <a:bodyPr wrap="square" lIns="0" tIns="0">
-            <a:spAutoFit/>
-          </a:bodyPr>
-          <a:lstStyle/>
-          <a:p>
-            <a:pPr>
-              <a:defRPr sz="2100" b="1">
-                <a:solidFill>
-                  <a:srgbClr val="ED1D24"/>
-                </a:solidFill>
-                <a:latin typeface="Arial"/>
-              </a:defRPr>
-            </a:pPr>
-            <a:r>
-              <a:rPr dirty="0"/>
-              <a:t>Annexure 2: Inbound Customer Portal &amp; </a:t>
-            </a:r>
-            <a:r>
-              <a:rPr dirty="0" err="1"/>
-              <a:t>AirBot</a:t>
-            </a:r>
-            <a:r>
-              <a:rPr dirty="0"/>
-              <a:t> Interface</a:t>
-            </a:r>
-          </a:p>
-        </p:txBody>
-      </p:sp>
-      <p:sp>
-        <p:nvSpPr>
-          <p:cNvPr id="5" name="TextBox 4"/>
-          <p:cNvSpPr txBox="1"/>
-          <p:nvPr/>
-        </p:nvSpPr>
-        <p:spPr>
-          <a:xfrm>
-            <a:off x="457200" y="1005840"/>
-            <a:ext cx="3840480" cy="3657600"/>
-          </a:xfrm>
-          <a:prstGeom prst="rect">
-            <a:avLst/>
-          </a:prstGeom>
-          <a:noFill/>
-        </p:spPr>
-        <p:txBody>
-          <a:bodyPr wrap="square" lIns="0" tIns="0">
-            <a:spAutoFit/>
-          </a:bodyPr>
-          <a:lstStyle/>
-          <a:p>
-            <a:pPr>
-              <a:spcAft>
-                <a:spcPts val="800"/>
-              </a:spcAft>
-              <a:defRPr sz="1300" b="1">
-                <a:solidFill>
-                  <a:srgbClr val="0F121C"/>
-                </a:solidFill>
-                <a:latin typeface="Arial"/>
-              </a:defRPr>
-            </a:pPr>
-            <a:r>
-              <a:t>Digitizing the Onboarding Funnel</a:t>
-            </a:r>
-          </a:p>
-          <a:p>
-            <a:pPr>
-              <a:spcAft>
-                <a:spcPts val="600"/>
-              </a:spcAft>
-              <a:defRPr sz="950" b="0">
-                <a:solidFill>
-                  <a:srgbClr val="212121"/>
-                </a:solidFill>
-                <a:latin typeface="Arial"/>
-              </a:defRPr>
-            </a:pPr>
-            <a:r>
-              <a:t>• Website Re-architecting: Designed a premium tab-based structure instead of long scroll sheets, streamlining categories for different household priorities.</a:t>
-            </a:r>
-          </a:p>
-          <a:p>
-            <a:pPr>
-              <a:spcAft>
-                <a:spcPts val="600"/>
-              </a:spcAft>
-              <a:defRPr sz="950" b="0">
-                <a:solidFill>
-                  <a:srgbClr val="212121"/>
-                </a:solidFill>
-                <a:latin typeface="Arial"/>
-              </a:defRPr>
-            </a:pPr>
-            <a:r>
-              <a:t>• AirBot Integration: AirBot acts as a frictionless digital concierge. It replaces standard sales pitch dialogue with multi-select service checklists and contextual profiling.</a:t>
-            </a:r>
-          </a:p>
-          <a:p>
-            <a:pPr>
-              <a:spcAft>
-                <a:spcPts val="600"/>
-              </a:spcAft>
-              <a:defRPr sz="950" b="0">
-                <a:solidFill>
-                  <a:srgbClr val="212121"/>
-                </a:solidFill>
-                <a:latin typeface="Arial"/>
-              </a:defRPr>
-            </a:pPr>
-            <a:r>
-              <a:t>• Autopay &amp; Coin Loops: The online checkout dynamically demonstrates monthly savings (₹50 discount) and Thanks Coins loyalty accumulation to increase signup rates.</a:t>
-            </a:r>
-          </a:p>
-        </p:txBody>
-      </p:sp>
       <p:pic>
         <p:nvPicPr>
           <p:cNvPr id="6" name="Picture 5" descr="bundle_choice_card.jpg"/>
@@ -7730,6 +7217,236 @@
           <a:prstGeom prst="rect">
             <a:avLst/>
           </a:prstGeom>
+        </p:spPr>
+      </p:pic>
+      <p:sp>
+        <p:nvSpPr>
+          <p:cNvPr id="7" name="TextBox 6"/>
+          <p:cNvSpPr txBox="1"/>
+          <p:nvPr/>
+        </p:nvSpPr>
+        <p:spPr>
+          <a:xfrm>
+            <a:off x="457200" y="182880"/>
+            <a:ext cx="8229600" cy="731520"/>
+          </a:xfrm>
+          <a:prstGeom prst="rect">
+            <a:avLst/>
+          </a:prstGeom>
+          <a:noFill/>
+        </p:spPr>
+        <p:txBody>
+          <a:bodyPr wrap="square" lIns="0" tIns="0">
+            <a:spAutoFit/>
+          </a:bodyPr>
+          <a:lstStyle/>
+          <a:p>
+            <a:pPr>
+              <a:defRPr sz="2100" b="1">
+                <a:solidFill>
+                  <a:srgbClr val="ED1D24"/>
+                </a:solidFill>
+                <a:latin typeface="Calibri"/>
+              </a:defRPr>
+            </a:pPr>
+            <a:r>
+              <a:t>Annexure 1: Primary Research &amp; Conjoint Choice Cards</a:t>
+            </a:r>
+          </a:p>
+        </p:txBody>
+      </p:sp>
+      <p:sp>
+        <p:nvSpPr>
+          <p:cNvPr id="8" name="Rounded Rectangle 7"/>
+          <p:cNvSpPr/>
+          <p:nvPr/>
+        </p:nvSpPr>
+        <p:spPr>
+          <a:xfrm>
+            <a:off x="457200" y="1005840"/>
+            <a:ext cx="3840480" cy="3657600"/>
+          </a:xfrm>
+          <a:prstGeom prst="roundRect">
+            <a:avLst/>
+          </a:prstGeom>
+          <a:solidFill>
+            <a:srgbClr val="F8F9FA"/>
+          </a:solidFill>
+          <a:ln w="12700">
+            <a:solidFill>
+              <a:srgbClr val="E4E6EB"/>
+            </a:solidFill>
+          </a:ln>
+        </p:spPr>
+        <p:style>
+          <a:lnRef idx="1">
+            <a:schemeClr val="accent1"/>
+          </a:lnRef>
+          <a:fillRef idx="3">
+            <a:schemeClr val="accent1"/>
+          </a:fillRef>
+          <a:effectRef idx="2">
+            <a:schemeClr val="accent1"/>
+          </a:effectRef>
+          <a:fontRef idx="minor">
+            <a:schemeClr val="lt1"/>
+          </a:fontRef>
+        </p:style>
+        <p:txBody>
+          <a:bodyPr rtlCol="0" anchor="t" wrap="square" lIns="137160" rIns="137160" tIns="164592" bIns="137160"/>
+          <a:lstStyle/>
+          <a:p>
+            <a:pPr algn="ctr">
+              <a:spcAft>
+                <a:spcPts val="800"/>
+              </a:spcAft>
+              <a:defRPr sz="1300" b="1">
+                <a:solidFill>
+                  <a:srgbClr val="0F121C"/>
+                </a:solidFill>
+                <a:latin typeface="Calibri"/>
+              </a:defRPr>
+            </a:pPr>
+            <a:r>
+              <a:t>Research Methodology &amp; Conjoint Analysis</a:t>
+            </a:r>
+          </a:p>
+          <a:p>
+            <a:pPr>
+              <a:spcAft>
+                <a:spcPts val="500"/>
+              </a:spcAft>
+              <a:defRPr sz="880" b="0">
+                <a:solidFill>
+                  <a:srgbClr val="212121"/>
+                </a:solidFill>
+                <a:latin typeface="Arial"/>
+              </a:defRPr>
+            </a:pPr>
+            <a:r>
+              <a:t>• Conjoint Setup: We deployed 4 binary choice questions directly comparing individual utilities vs. their bundled Altura Home counterparts (Choice Card Starter, Connect, Family Secure, and Infinite).</a:t>
+            </a:r>
+          </a:p>
+          <a:p>
+            <a:pPr>
+              <a:spcAft>
+                <a:spcPts val="500"/>
+              </a:spcAft>
+              <a:defRPr sz="880" b="0">
+                <a:solidFill>
+                  <a:srgbClr val="212121"/>
+                </a:solidFill>
+                <a:latin typeface="Arial"/>
+              </a:defRPr>
+            </a:pPr>
+            <a:r>
+              <a:t>• Goal: This Discrete Choice Conjoint Experiment isolates exactly where price sensitivity breaks and maps household utility values.</a:t>
+            </a:r>
+          </a:p>
+          <a:p>
+            <a:pPr>
+              <a:spcAft>
+                <a:spcPts val="500"/>
+              </a:spcAft>
+              <a:defRPr sz="880" b="0">
+                <a:solidFill>
+                  <a:srgbClr val="212121"/>
+                </a:solidFill>
+                <a:latin typeface="Arial"/>
+              </a:defRPr>
+            </a:pPr>
+            <a:r>
+              <a:t>• Quantifying SPOF: Our survey includes agree/disagree statements to map network reliability concerns and data privacy barriers.</a:t>
+            </a:r>
+          </a:p>
+          <a:p>
+            <a:pPr>
+              <a:spcAft>
+                <a:spcPts val="500"/>
+              </a:spcAft>
+              <a:defRPr sz="880" b="0">
+                <a:solidFill>
+                  <a:srgbClr val="212121"/>
+                </a:solidFill>
+                <a:latin typeface="Arial"/>
+              </a:defRPr>
+            </a:pPr>
+            <a:r>
+              <a:t>• Uploading Cards: The generated card graphics (pictured right) help respondents visually compare price-to-benefit ratios.</a:t>
+            </a:r>
+          </a:p>
+        </p:txBody>
+      </p:sp>
+      <p:sp>
+        <p:nvSpPr>
+          <p:cNvPr id="9" name="Rectangle 8"/>
+          <p:cNvSpPr/>
+          <p:nvPr/>
+        </p:nvSpPr>
+        <p:spPr>
+          <a:xfrm>
+            <a:off x="502920" y="1005840"/>
+            <a:ext cx="3749040" cy="73152"/>
+          </a:xfrm>
+          <a:prstGeom prst="rect">
+            <a:avLst/>
+          </a:prstGeom>
+          <a:solidFill>
+            <a:srgbClr val="0F121C"/>
+          </a:solidFill>
+          <a:ln>
+            <a:noFill/>
+          </a:ln>
+        </p:spPr>
+        <p:style>
+          <a:lnRef idx="1">
+            <a:schemeClr val="accent1"/>
+          </a:lnRef>
+          <a:fillRef idx="3">
+            <a:schemeClr val="accent1"/>
+          </a:fillRef>
+          <a:effectRef idx="2">
+            <a:schemeClr val="accent1"/>
+          </a:effectRef>
+          <a:fontRef idx="minor">
+            <a:schemeClr val="lt1"/>
+          </a:fontRef>
+        </p:style>
+        <p:txBody>
+          <a:bodyPr rtlCol="0" anchor="ctr"/>
+          <a:lstStyle/>
+          <a:p>
+            <a:pPr algn="ctr"/>
+          </a:p>
+        </p:txBody>
+      </p:sp>
+      <p:pic>
+        <p:nvPicPr>
+          <p:cNvPr id="10" name="Picture 9" descr="image.jpg"/>
+          <p:cNvPicPr>
+            <a:picLocks noChangeAspect="1"/>
+          </p:cNvPicPr>
+          <p:nvPr/>
+        </p:nvPicPr>
+        <p:blipFill>
+          <a:blip r:embed="rId4"/>
+          <a:stretch>
+            <a:fillRect/>
+          </a:stretch>
+        </p:blipFill>
+        <p:spPr>
+          <a:xfrm>
+            <a:off x="4572000" y="1188720"/>
+            <a:ext cx="4114800" cy="3086100"/>
+          </a:xfrm>
+          <a:prstGeom prst="rect">
+            <a:avLst/>
+          </a:prstGeom>
+          <a:ln w="12700">
+            <a:solidFill>
+              <a:srgbClr val="E4E6EB"/>
+            </a:solidFill>
+          </a:ln>
         </p:spPr>
       </p:pic>
     </p:spTree>
@@ -7808,7 +7525,7 @@
         </p:nvSpPr>
         <p:spPr>
           <a:xfrm>
-            <a:off x="457200" y="602550"/>
+            <a:off x="457200" y="182880"/>
             <a:ext cx="8229600" cy="731520"/>
           </a:xfrm>
           <a:prstGeom prst="rect">
@@ -7827,39 +7544,57 @@
                 <a:solidFill>
                   <a:srgbClr val="ED1D24"/>
                 </a:solidFill>
-                <a:latin typeface="Arial"/>
+                <a:latin typeface="Calibri"/>
               </a:defRPr>
             </a:pPr>
             <a:r>
-              <a:rPr dirty="0"/>
-              <a:t>Annexure 3: Data-Driven Target Cohorts &amp; Economics</a:t>
+              <a:t>Annexure 2: Inbound Customer Portal &amp; Choice Matrices</a:t>
             </a:r>
           </a:p>
         </p:txBody>
       </p:sp>
       <p:sp>
         <p:nvSpPr>
-          <p:cNvPr id="5" name="TextBox 4"/>
-          <p:cNvSpPr txBox="1"/>
+          <p:cNvPr id="5" name="Rounded Rectangle 4"/>
+          <p:cNvSpPr/>
           <p:nvPr/>
         </p:nvSpPr>
         <p:spPr>
           <a:xfrm>
             <a:off x="457200" y="1005840"/>
-            <a:ext cx="8229600" cy="3657600"/>
+            <a:ext cx="3840480" cy="3657600"/>
           </a:xfrm>
-          <a:prstGeom prst="rect">
+          <a:prstGeom prst="roundRect">
             <a:avLst/>
           </a:prstGeom>
-          <a:noFill/>
+          <a:solidFill>
+            <a:srgbClr val="F8F9FA"/>
+          </a:solidFill>
+          <a:ln w="12700">
+            <a:solidFill>
+              <a:srgbClr val="E4E6EB"/>
+            </a:solidFill>
+          </a:ln>
         </p:spPr>
+        <p:style>
+          <a:lnRef idx="1">
+            <a:schemeClr val="accent1"/>
+          </a:lnRef>
+          <a:fillRef idx="3">
+            <a:schemeClr val="accent1"/>
+          </a:fillRef>
+          <a:effectRef idx="2">
+            <a:schemeClr val="accent1"/>
+          </a:effectRef>
+          <a:fontRef idx="minor">
+            <a:schemeClr val="lt1"/>
+          </a:fontRef>
+        </p:style>
         <p:txBody>
-          <a:bodyPr wrap="square" lIns="0" tIns="0">
-            <a:spAutoFit/>
-          </a:bodyPr>
+          <a:bodyPr rtlCol="0" anchor="t" wrap="square" lIns="137160" rIns="137160" tIns="164592" bIns="137160"/>
           <a:lstStyle/>
           <a:p>
-            <a:pPr>
+            <a:pPr algn="ctr">
               <a:spcAft>
                 <a:spcPts val="800"/>
               </a:spcAft>
@@ -7867,19 +7602,19 @@
                 <a:solidFill>
                   <a:srgbClr val="0F121C"/>
                 </a:solidFill>
-                <a:latin typeface="Arial"/>
+                <a:latin typeface="Calibri"/>
               </a:defRPr>
             </a:pPr>
             <a:r>
-              <a:t>AI-Targeted Cross-Sell Opportunities (Exhibits 4 &amp; 5)</a:t>
+              <a:t>Digitizing the Onboarding Funnel</a:t>
             </a:r>
           </a:p>
           <a:p>
             <a:pPr>
               <a:spcAft>
-                <a:spcPts val="600"/>
-              </a:spcAft>
-              <a:defRPr sz="950" b="0">
+                <a:spcPts val="500"/>
+              </a:spcAft>
+              <a:defRPr sz="880" b="0">
                 <a:solidFill>
                   <a:srgbClr val="212121"/>
                 </a:solidFill>
@@ -7887,15 +7622,15 @@
               </a:defRPr>
             </a:pPr>
             <a:r>
-              <a:t>• Cohort A: High-Intent Overlaps (2.5M Users): Target the 2.5 million households subscribing to both Broadband and DTH. Since they are already double-billed, they represent low-hanging fruit for the 'Connect' or 'Family Secure' bundles.</a:t>
+              <a:t>• Website Re-architecting: Designed a premium tab-based structure instead of long scroll sheets, streamlining categories for different household priorities.</a:t>
             </a:r>
           </a:p>
           <a:p>
             <a:pPr>
               <a:spcAft>
-                <a:spcPts val="600"/>
-              </a:spcAft>
-              <a:defRPr sz="950" b="0">
+                <a:spcPts val="500"/>
+              </a:spcAft>
+              <a:defRPr sz="880" b="0">
                 <a:solidFill>
                   <a:srgbClr val="212121"/>
                 </a:solidFill>
@@ -7903,15 +7638,15 @@
               </a:defRPr>
             </a:pPr>
             <a:r>
-              <a:t>• Cohort B: DTH-Only Accounts (16M Users): DTH is expected to decline due to streaming (Exhibit 2). Transitioning these 16 million siloed accounts into converged Fiber+SIM+TV bundles saves them money while preventing DTH cord-cutting.</a:t>
+              <a:t>• AirBot Integration: AirBot acts as a frictionless digital concierge. It replaces standard sales pitch dialogue with multi-select service checklists and contextual profiling.</a:t>
             </a:r>
           </a:p>
           <a:p>
             <a:pPr>
               <a:spcAft>
-                <a:spcPts val="600"/>
-              </a:spcAft>
-              <a:defRPr sz="950" b="0">
+                <a:spcPts val="500"/>
+              </a:spcAft>
+              <a:defRPr sz="880" b="0">
                 <a:solidFill>
                   <a:srgbClr val="212121"/>
                 </a:solidFill>
@@ -7919,11 +7654,83 @@
               </a:defRPr>
             </a:pPr>
             <a:r>
-              <a:t>• Channel Optimization: Digital channel CAC is 50% lower than direct sales (Broadband: ₹220 vs ₹450), but direct sales secure higher Month-4 retention. We route online AirBot leads directly to concierge field technicians to optimize conversion.</a:t>
+              <a:t>• Autopay &amp; Coin Loops: The online checkout dynamically demonstrates monthly savings (₹50 discount) and Thanks Coins loyalty accumulation to increase signup rates.</a:t>
             </a:r>
           </a:p>
         </p:txBody>
       </p:sp>
+      <p:sp>
+        <p:nvSpPr>
+          <p:cNvPr id="6" name="Rectangle 5"/>
+          <p:cNvSpPr/>
+          <p:nvPr/>
+        </p:nvSpPr>
+        <p:spPr>
+          <a:xfrm>
+            <a:off x="502920" y="1005840"/>
+            <a:ext cx="3749040" cy="73152"/>
+          </a:xfrm>
+          <a:prstGeom prst="rect">
+            <a:avLst/>
+          </a:prstGeom>
+          <a:solidFill>
+            <a:srgbClr val="3498DB"/>
+          </a:solidFill>
+          <a:ln>
+            <a:noFill/>
+          </a:ln>
+        </p:spPr>
+        <p:style>
+          <a:lnRef idx="1">
+            <a:schemeClr val="accent1"/>
+          </a:lnRef>
+          <a:fillRef idx="3">
+            <a:schemeClr val="accent1"/>
+          </a:fillRef>
+          <a:effectRef idx="2">
+            <a:schemeClr val="accent1"/>
+          </a:effectRef>
+          <a:fontRef idx="minor">
+            <a:schemeClr val="lt1"/>
+          </a:fontRef>
+        </p:style>
+        <p:txBody>
+          <a:bodyPr rtlCol="0" anchor="ctr"/>
+          <a:lstStyle/>
+          <a:p>
+            <a:pPr algn="ctr"/>
+          </a:p>
+        </p:txBody>
+      </p:sp>
+      <p:pic>
+        <p:nvPicPr>
+          <p:cNvPr id="7" name="Picture 6" descr="image.jpg"/>
+          <p:cNvPicPr>
+            <a:picLocks noChangeAspect="1"/>
+          </p:cNvPicPr>
+          <p:nvPr/>
+        </p:nvPicPr>
+        <p:blipFill>
+          <a:blip r:embed="rId3"/>
+          <a:stretch>
+            <a:fillRect/>
+          </a:stretch>
+        </p:blipFill>
+        <p:spPr>
+          <a:xfrm>
+            <a:off x="4572000" y="1188720"/>
+            <a:ext cx="4114800" cy="3086100"/>
+          </a:xfrm>
+          <a:prstGeom prst="rect">
+            <a:avLst/>
+          </a:prstGeom>
+          <a:ln w="12700">
+            <a:solidFill>
+              <a:srgbClr val="E4E6EB"/>
+            </a:solidFill>
+          </a:ln>
+        </p:spPr>
+      </p:pic>
     </p:spTree>
   </p:cSld>
   <p:clrMapOvr>
@@ -8000,7 +7807,7 @@
         </p:nvSpPr>
         <p:spPr>
           <a:xfrm>
-            <a:off x="424150" y="602550"/>
+            <a:off x="457200" y="182880"/>
             <a:ext cx="8229600" cy="731520"/>
           </a:xfrm>
           <a:prstGeom prst="rect">
@@ -8019,19 +7826,19 @@
                 <a:solidFill>
                   <a:srgbClr val="ED1D24"/>
                 </a:solidFill>
-                <a:latin typeface="Arial"/>
+                <a:latin typeface="Calibri"/>
               </a:defRPr>
             </a:pPr>
             <a:r>
-              <a:t>Annexure 4: Bundle Pricing Model &amp; EBITDA Accretion</a:t>
+              <a:t>Annexure 3: Data-Driven Target Cohorts &amp; Economics</a:t>
             </a:r>
           </a:p>
         </p:txBody>
       </p:sp>
       <p:sp>
         <p:nvSpPr>
-          <p:cNvPr id="5" name="TextBox 4"/>
-          <p:cNvSpPr txBox="1"/>
+          <p:cNvPr id="5" name="Rounded Rectangle 4"/>
+          <p:cNvSpPr/>
           <p:nvPr/>
         </p:nvSpPr>
         <p:spPr>
@@ -8039,18 +7846,37 @@
             <a:off x="457200" y="1005840"/>
             <a:ext cx="8229600" cy="3657600"/>
           </a:xfrm>
-          <a:prstGeom prst="rect">
+          <a:prstGeom prst="roundRect">
             <a:avLst/>
           </a:prstGeom>
-          <a:noFill/>
+          <a:solidFill>
+            <a:srgbClr val="F8F9FA"/>
+          </a:solidFill>
+          <a:ln w="12700">
+            <a:solidFill>
+              <a:srgbClr val="E4E6EB"/>
+            </a:solidFill>
+          </a:ln>
         </p:spPr>
+        <p:style>
+          <a:lnRef idx="1">
+            <a:schemeClr val="accent1"/>
+          </a:lnRef>
+          <a:fillRef idx="3">
+            <a:schemeClr val="accent1"/>
+          </a:fillRef>
+          <a:effectRef idx="2">
+            <a:schemeClr val="accent1"/>
+          </a:effectRef>
+          <a:fontRef idx="minor">
+            <a:schemeClr val="lt1"/>
+          </a:fontRef>
+        </p:style>
         <p:txBody>
-          <a:bodyPr wrap="square" lIns="0" tIns="0">
-            <a:spAutoFit/>
-          </a:bodyPr>
+          <a:bodyPr rtlCol="0" anchor="t" wrap="square" lIns="137160" rIns="137160" tIns="164592" bIns="137160"/>
           <a:lstStyle/>
           <a:p>
-            <a:pPr>
+            <a:pPr algn="ctr">
               <a:spcAft>
                 <a:spcPts val="800"/>
               </a:spcAft>
@@ -8058,11 +7884,11 @@
                 <a:solidFill>
                   <a:srgbClr val="0F121C"/>
                 </a:solidFill>
-                <a:latin typeface="Arial"/>
+                <a:latin typeface="Calibri"/>
               </a:defRPr>
             </a:pPr>
             <a:r>
-              <a:t>Converged Pricing Sheets &amp; EBITDA Margins (Exhibits 1 &amp; 2)</a:t>
+              <a:t>AI-Targeted Cross-Sell Opportunities (Exhibits 4 &amp; 5)</a:t>
             </a:r>
           </a:p>
           <a:p>
@@ -8070,7 +7896,7 @@
               <a:spcAft>
                 <a:spcPts val="600"/>
               </a:spcAft>
-              <a:defRPr sz="950" b="0">
+              <a:defRPr sz="900" b="0">
                 <a:solidFill>
                   <a:srgbClr val="212121"/>
                 </a:solidFill>
@@ -8078,7 +7904,7 @@
               </a:defRPr>
             </a:pPr>
             <a:r>
-              <a:t>• Individual vs. Bundle Price Matrix:</a:t>
+              <a:t>• Cohort A: High-Intent Overlaps (2.5M Users): Target the 2.5 million households subscribing to both Broadband and DTH. Since they are already double-billed, they represent low-hanging fruit for the 'Connect' or 'Family Secure' bundles.</a:t>
             </a:r>
           </a:p>
           <a:p>
@@ -8086,7 +7912,7 @@
               <a:spcAft>
                 <a:spcPts val="600"/>
               </a:spcAft>
-              <a:defRPr sz="950" b="0">
+              <a:defRPr sz="900" b="0">
                 <a:solidFill>
                   <a:srgbClr val="212121"/>
                 </a:solidFill>
@@ -8094,7 +7920,7 @@
               </a:defRPr>
             </a:pPr>
             <a:r>
-              <a:t>   - Standalone Sum: Broadband (₹599) + 2 SIMs (₹700) + Xstream Box (₹250) + Google One (₹209) + Xsafe CCTV (₹150) + Bank (₹99) = ₹2,006/mo.</a:t>
+              <a:t>• Cohort B: DTH-Only Accounts (16M Users): DTH is expected to decline due to streaming (Exhibit 2). Transitioning these 16 million siloed accounts into converged Fiber+SIM+TV bundles saves them money while preventing DTH cord-cutting.</a:t>
             </a:r>
           </a:p>
           <a:p>
@@ -8102,7 +7928,7 @@
               <a:spcAft>
                 <a:spcPts val="600"/>
               </a:spcAft>
-              <a:defRPr sz="950" b="0">
+              <a:defRPr sz="900" b="0">
                 <a:solidFill>
                   <a:srgbClr val="212121"/>
                 </a:solidFill>
@@ -8110,40 +7936,51 @@
               </a:defRPr>
             </a:pPr>
             <a:r>
-              <a:t>   - Consolidated Family Secure: ₹1,499/mo (Saves ₹507/mo or 25% discount). Promoted at ₹999/mo for the first 3 months to destroy switching inertia.</a:t>
+              <a:t>• Channel Optimization: Digital channel CAC is 50% lower than direct sales (Broadband: ₹220 vs ₹450), but direct sales secure higher Month-4 retention. We route online AirBot leads directly to concierge field technicians to optimize conversion.</a:t>
             </a:r>
           </a:p>
-          <a:p>
-            <a:pPr>
-              <a:spcAft>
-                <a:spcPts val="600"/>
-              </a:spcAft>
-              <a:defRPr sz="950" b="0">
-                <a:solidFill>
-                  <a:srgbClr val="212121"/>
-                </a:solidFill>
-                <a:latin typeface="Arial"/>
-              </a:defRPr>
-            </a:pPr>
-            <a:r>
-              <a:t>• Margin Protection: Home Surveillance holds the highest EBITDA margin at 35% (Exhibit 1) and is growing at 35.7% CAGR (Exhibit 2). By bundling Xsafe cameras into Family Secure and Infinite tiers, we offset lower TV margins (12% EBITDA) and drive net margin expansion.</a:t>
-            </a:r>
-          </a:p>
-          <a:p>
-            <a:pPr>
-              <a:spcAft>
-                <a:spcPts val="600"/>
-              </a:spcAft>
-              <a:defRPr sz="950" b="0">
-                <a:solidFill>
-                  <a:srgbClr val="212121"/>
-                </a:solidFill>
-                <a:latin typeface="Arial"/>
-              </a:defRPr>
-            </a:pPr>
-            <a:r>
-              <a:t>• Retention Leverage: Reducing household churn from 22% down to 5% lifts customer lifetime value (LTV) by over 400%, easily amortizing the initial ₹999/mo introductory launch promo cost.</a:t>
-            </a:r>
+        </p:txBody>
+      </p:sp>
+      <p:sp>
+        <p:nvSpPr>
+          <p:cNvPr id="6" name="Rectangle 5"/>
+          <p:cNvSpPr/>
+          <p:nvPr/>
+        </p:nvSpPr>
+        <p:spPr>
+          <a:xfrm>
+            <a:off x="502920" y="1005840"/>
+            <a:ext cx="8138160" cy="73152"/>
+          </a:xfrm>
+          <a:prstGeom prst="rect">
+            <a:avLst/>
+          </a:prstGeom>
+          <a:solidFill>
+            <a:srgbClr val="0F121C"/>
+          </a:solidFill>
+          <a:ln>
+            <a:noFill/>
+          </a:ln>
+        </p:spPr>
+        <p:style>
+          <a:lnRef idx="1">
+            <a:schemeClr val="accent1"/>
+          </a:lnRef>
+          <a:fillRef idx="3">
+            <a:schemeClr val="accent1"/>
+          </a:fillRef>
+          <a:effectRef idx="2">
+            <a:schemeClr val="accent1"/>
+          </a:effectRef>
+          <a:fontRef idx="minor">
+            <a:schemeClr val="lt1"/>
+          </a:fontRef>
+        </p:style>
+        <p:txBody>
+          <a:bodyPr rtlCol="0" anchor="ctr"/>
+          <a:lstStyle/>
+          <a:p>
+            <a:pPr algn="ctr"/>
           </a:p>
         </p:txBody>
       </p:sp>
@@ -8206,145 +8043,6 @@
           </a:prstGeom>
         </p:spPr>
       </p:pic>
-      <p:sp>
-        <p:nvSpPr>
-          <p:cNvPr id="4" name="TextBox 3"/>
-          <p:cNvSpPr txBox="1"/>
-          <p:nvPr/>
-        </p:nvSpPr>
-        <p:spPr>
-          <a:xfrm>
-            <a:off x="457200" y="182880"/>
-            <a:ext cx="8229600" cy="731520"/>
-          </a:xfrm>
-          <a:prstGeom prst="rect">
-            <a:avLst/>
-          </a:prstGeom>
-          <a:noFill/>
-        </p:spPr>
-        <p:txBody>
-          <a:bodyPr wrap="square" lIns="0" tIns="0">
-            <a:spAutoFit/>
-          </a:bodyPr>
-          <a:lstStyle/>
-          <a:p>
-            <a:pPr>
-              <a:defRPr sz="2100" b="1">
-                <a:solidFill>
-                  <a:srgbClr val="ED1D24"/>
-                </a:solidFill>
-                <a:latin typeface="Calibri"/>
-              </a:defRPr>
-            </a:pPr>
-            <a:r>
-              <a:t>Altura Home: Inbound GTM Strategy &amp; Onboarding Platform</a:t>
-            </a:r>
-          </a:p>
-        </p:txBody>
-      </p:sp>
-      <p:sp>
-        <p:nvSpPr>
-          <p:cNvPr id="5" name="TextBox 4"/>
-          <p:cNvSpPr txBox="1"/>
-          <p:nvPr/>
-        </p:nvSpPr>
-        <p:spPr>
-          <a:xfrm>
-            <a:off x="457200" y="1005840"/>
-            <a:ext cx="3657600" cy="3840480"/>
-          </a:xfrm>
-          <a:prstGeom prst="rect">
-            <a:avLst/>
-          </a:prstGeom>
-          <a:noFill/>
-        </p:spPr>
-        <p:txBody>
-          <a:bodyPr wrap="square" lIns="0" tIns="0">
-            <a:spAutoFit/>
-          </a:bodyPr>
-          <a:lstStyle/>
-          <a:p>
-            <a:pPr>
-              <a:spcAft>
-                <a:spcPts val="600"/>
-              </a:spcAft>
-              <a:defRPr sz="1300" b="1">
-                <a:solidFill>
-                  <a:srgbClr val="0F121C"/>
-                </a:solidFill>
-                <a:latin typeface="Calibri"/>
-              </a:defRPr>
-            </a:pPr>
-            <a:r>
-              <a:t>1. Inbound Strategy &amp; Pricing Psychology</a:t>
-            </a:r>
-          </a:p>
-          <a:p>
-            <a:pPr>
-              <a:spcAft>
-                <a:spcPts val="500"/>
-              </a:spcAft>
-              <a:defRPr sz="850" b="0">
-                <a:solidFill>
-                  <a:srgbClr val="212121"/>
-                </a:solidFill>
-                <a:latin typeface="Arial"/>
-              </a:defRPr>
-            </a:pPr>
-            <a:r>
-              <a:t>• Inbound Focus: Prioritize converting our existing 20 million active relationships (siloed accounts) to double wallet share, rather than high-CAC outbound acquisition.</a:t>
-            </a:r>
-          </a:p>
-          <a:p>
-            <a:pPr>
-              <a:spcAft>
-                <a:spcPts val="500"/>
-              </a:spcAft>
-              <a:defRPr sz="850" b="0">
-                <a:solidFill>
-                  <a:srgbClr val="212121"/>
-                </a:solidFill>
-                <a:latin typeface="Arial"/>
-              </a:defRPr>
-            </a:pPr>
-            <a:r>
-              <a:t>• 4 Bundle Portfolio: Altura Starter (₹499/mo), Altura Connect (₹999/mo), Family Secure (₹1,499/mo), and Altura Infinite (₹2,999/mo).</a:t>
-            </a:r>
-          </a:p>
-          <a:p>
-            <a:pPr>
-              <a:spcAft>
-                <a:spcPts val="500"/>
-              </a:spcAft>
-              <a:defRPr sz="850" b="0">
-                <a:solidFill>
-                  <a:srgbClr val="212121"/>
-                </a:solidFill>
-                <a:latin typeface="Arial"/>
-              </a:defRPr>
-            </a:pPr>
-            <a:r>
-              <a:t>• Bundle Psychology &amp; Habit Loop: We discounted the Family Secure bundle to ₹999/mo for the first 3 months, equating it to the price of the basic Connect bundle. Users choose the higher-tier plan due to price-equivalence. During the 3-month trial, they develop a habit around 100 Mbps fiber, smart TV, and Xsafe cameras. Post-trial, they continue at the ₹1,499/mo standard rate, lifting ARPU.</a:t>
-            </a:r>
-          </a:p>
-          <a:p>
-            <a:pPr>
-              <a:spcAft>
-                <a:spcPts val="500"/>
-              </a:spcAft>
-              <a:defRPr sz="850" b="0">
-                <a:solidFill>
-                  <a:srgbClr val="212121"/>
-                </a:solidFill>
-                <a:latin typeface="Arial"/>
-              </a:defRPr>
-            </a:pPr>
-            <a:r>
-              <a:t>• Outbound Note: Direct sales can utilize targeted SMS/App push to overlaps, but the core engine is inbound portal conversion.</a:t>
-            </a:r>
-          </a:p>
-        </p:txBody>
-      </p:sp>
       <p:pic>
         <p:nvPicPr>
           <p:cNvPr id="6" name="Picture 5" descr="screenshot_airbot.png"/>
@@ -8369,58 +8067,6 @@
           </a:prstGeom>
         </p:spPr>
       </p:pic>
-      <p:sp>
-        <p:nvSpPr>
-          <p:cNvPr id="7" name="TextBox 6"/>
-          <p:cNvSpPr txBox="1"/>
-          <p:nvPr/>
-        </p:nvSpPr>
-        <p:spPr>
-          <a:xfrm>
-            <a:off x="5486400" y="1005840"/>
-            <a:ext cx="3200400" cy="1097280"/>
-          </a:xfrm>
-          <a:prstGeom prst="rect">
-            <a:avLst/>
-          </a:prstGeom>
-          <a:noFill/>
-        </p:spPr>
-        <p:txBody>
-          <a:bodyPr wrap="square" lIns="0" tIns="0">
-            <a:spAutoFit/>
-          </a:bodyPr>
-          <a:lstStyle/>
-          <a:p>
-            <a:pPr>
-              <a:spcAft>
-                <a:spcPts val="200"/>
-              </a:spcAft>
-              <a:defRPr sz="1050" b="1">
-                <a:solidFill>
-                  <a:srgbClr val="0F121C"/>
-                </a:solidFill>
-                <a:latin typeface="Calibri"/>
-              </a:defRPr>
-            </a:pPr>
-            <a:r>
-              <a:t>AirBot AI Concierge</a:t>
-            </a:r>
-          </a:p>
-          <a:p>
-            <a:pPr>
-              <a:defRPr sz="850" b="0">
-                <a:solidFill>
-                  <a:srgbClr val="212121"/>
-                </a:solidFill>
-                <a:latin typeface="Arial"/>
-              </a:defRPr>
-            </a:pPr>
-            <a:r>
-              <a:t>Our integrated AI assistant dynamically profiles household sizes and service priorities using multi-select checklist filters, routing users to optimal packages and reducing funnel drop-off.</a:t>
-            </a:r>
-          </a:p>
-        </p:txBody>
-      </p:sp>
       <p:pic>
         <p:nvPicPr>
           <p:cNvPr id="8" name="Picture 7" descr="screenshot_packages.png"/>
@@ -8445,58 +8091,6 @@
           </a:prstGeom>
         </p:spPr>
       </p:pic>
-      <p:sp>
-        <p:nvSpPr>
-          <p:cNvPr id="9" name="TextBox 8"/>
-          <p:cNvSpPr txBox="1"/>
-          <p:nvPr/>
-        </p:nvSpPr>
-        <p:spPr>
-          <a:xfrm>
-            <a:off x="6309360" y="2286000"/>
-            <a:ext cx="2377440" cy="1033271"/>
-          </a:xfrm>
-          <a:prstGeom prst="rect">
-            <a:avLst/>
-          </a:prstGeom>
-          <a:noFill/>
-        </p:spPr>
-        <p:txBody>
-          <a:bodyPr wrap="square" lIns="0" tIns="0">
-            <a:spAutoFit/>
-          </a:bodyPr>
-          <a:lstStyle/>
-          <a:p>
-            <a:pPr>
-              <a:spcAft>
-                <a:spcPts val="200"/>
-              </a:spcAft>
-              <a:defRPr sz="1050" b="1">
-                <a:solidFill>
-                  <a:srgbClr val="0F121C"/>
-                </a:solidFill>
-                <a:latin typeface="Calibri"/>
-              </a:defRPr>
-            </a:pPr>
-            <a:r>
-              <a:t>Transparent Plans &amp; Packages</a:t>
-            </a:r>
-          </a:p>
-          <a:p>
-            <a:pPr>
-              <a:defRPr sz="850" b="0">
-                <a:solidFill>
-                  <a:srgbClr val="212121"/>
-                </a:solidFill>
-                <a:latin typeface="Arial"/>
-              </a:defRPr>
-            </a:pPr>
-            <a:r>
-              <a:t>Showcases pre-calculated tiers with clear highlight cards on the Family Secure ₹999/mo promo to trigger the price-equivalence purchase loop.</a:t>
-            </a:r>
-          </a:p>
-        </p:txBody>
-      </p:sp>
       <p:pic>
         <p:nvPicPr>
           <p:cNvPr id="10" name="Picture 9" descr="screenshot_customizer.png"/>
@@ -8529,8 +8123,8 @@
         </p:nvSpPr>
         <p:spPr>
           <a:xfrm>
-            <a:off x="6309360" y="3474720"/>
-            <a:ext cx="2377440" cy="1033271"/>
+            <a:off x="457200" y="182880"/>
+            <a:ext cx="8229600" cy="731520"/>
           </a:xfrm>
           <a:prstGeom prst="rect">
             <a:avLst/>
@@ -8544,10 +8138,65 @@
           <a:lstStyle/>
           <a:p>
             <a:pPr>
-              <a:spcAft>
-                <a:spcPts val="200"/>
-              </a:spcAft>
-              <a:defRPr sz="1050" b="1">
+              <a:defRPr sz="2100" b="1">
+                <a:solidFill>
+                  <a:srgbClr val="ED1D24"/>
+                </a:solidFill>
+                <a:latin typeface="Calibri"/>
+              </a:defRPr>
+            </a:pPr>
+            <a:r>
+              <a:t>Annexure 4: Bundle Pricing Model &amp; EBITDA Accretion</a:t>
+            </a:r>
+          </a:p>
+        </p:txBody>
+      </p:sp>
+      <p:sp>
+        <p:nvSpPr>
+          <p:cNvPr id="12" name="Rounded Rectangle 11"/>
+          <p:cNvSpPr/>
+          <p:nvPr/>
+        </p:nvSpPr>
+        <p:spPr>
+          <a:xfrm>
+            <a:off x="457200" y="1005840"/>
+            <a:ext cx="8229600" cy="3657600"/>
+          </a:xfrm>
+          <a:prstGeom prst="roundRect">
+            <a:avLst/>
+          </a:prstGeom>
+          <a:solidFill>
+            <a:srgbClr val="F8F9FA"/>
+          </a:solidFill>
+          <a:ln w="12700">
+            <a:solidFill>
+              <a:srgbClr val="E4E6EB"/>
+            </a:solidFill>
+          </a:ln>
+        </p:spPr>
+        <p:style>
+          <a:lnRef idx="1">
+            <a:schemeClr val="accent1"/>
+          </a:lnRef>
+          <a:fillRef idx="3">
+            <a:schemeClr val="accent1"/>
+          </a:fillRef>
+          <a:effectRef idx="2">
+            <a:schemeClr val="accent1"/>
+          </a:effectRef>
+          <a:fontRef idx="minor">
+            <a:schemeClr val="lt1"/>
+          </a:fontRef>
+        </p:style>
+        <p:txBody>
+          <a:bodyPr rtlCol="0" anchor="t" wrap="square" lIns="137160" rIns="137160" tIns="164592" bIns="137160"/>
+          <a:lstStyle/>
+          <a:p>
+            <a:pPr algn="ctr">
+              <a:spcAft>
+                <a:spcPts val="800"/>
+              </a:spcAft>
+              <a:defRPr sz="1300" b="1">
                 <a:solidFill>
                   <a:srgbClr val="0F121C"/>
                 </a:solidFill>
@@ -8555,12 +8204,15 @@
               </a:defRPr>
             </a:pPr>
             <a:r>
-              <a:t>Build Your Custom Bundle</a:t>
+              <a:t>Converged Pricing Sheets &amp; EBITDA Margins (Exhibits 1 &amp; 2)</a:t>
             </a:r>
           </a:p>
           <a:p>
             <a:pPr>
-              <a:defRPr sz="850" b="0">
+              <a:spcAft>
+                <a:spcPts val="600"/>
+              </a:spcAft>
+              <a:defRPr sz="900" b="0">
                 <a:solidFill>
                   <a:srgbClr val="212121"/>
                 </a:solidFill>
@@ -8568,8 +8220,115 @@
               </a:defRPr>
             </a:pPr>
             <a:r>
-              <a:t>Replaces rigid plans. Users pick only what they use (Fiber speed, SIM count, Cameras) and calculate dynamic costs, eliminating the utility waste of unused services.</a:t>
+              <a:t>• Individual vs. Bundle Price Matrix:</a:t>
             </a:r>
+          </a:p>
+          <a:p>
+            <a:pPr>
+              <a:spcAft>
+                <a:spcPts val="600"/>
+              </a:spcAft>
+              <a:defRPr sz="900" b="0">
+                <a:solidFill>
+                  <a:srgbClr val="212121"/>
+                </a:solidFill>
+                <a:latin typeface="Arial"/>
+              </a:defRPr>
+            </a:pPr>
+            <a:r>
+              <a:t>   - Standalone Sum: Broadband (₹599) + 2 SIMs (₹700) + Xstream Box (₹250) + Google One (₹209) + Xsafe CCTV (₹150) + Bank (₹99) = ₹2,006/mo.</a:t>
+            </a:r>
+          </a:p>
+          <a:p>
+            <a:pPr>
+              <a:spcAft>
+                <a:spcPts val="600"/>
+              </a:spcAft>
+              <a:defRPr sz="900" b="0">
+                <a:solidFill>
+                  <a:srgbClr val="212121"/>
+                </a:solidFill>
+                <a:latin typeface="Arial"/>
+              </a:defRPr>
+            </a:pPr>
+            <a:r>
+              <a:t>   - Consolidated Family Secure: ₹1,499/mo (Saves ₹507/mo or 25% discount). Promoted at ₹999/mo for the first 3 months to destroy switching inertia.</a:t>
+            </a:r>
+          </a:p>
+          <a:p>
+            <a:pPr>
+              <a:spcAft>
+                <a:spcPts val="600"/>
+              </a:spcAft>
+              <a:defRPr sz="900" b="0">
+                <a:solidFill>
+                  <a:srgbClr val="212121"/>
+                </a:solidFill>
+                <a:latin typeface="Arial"/>
+              </a:defRPr>
+            </a:pPr>
+            <a:r>
+              <a:t>• Margin Protection: Home Surveillance holds the highest EBITDA margin at 35% (Exhibit 1) and is growing at 35.7% CAGR (Exhibit 2). By bundling Xsafe cameras into Family Secure and Infinite tiers, we offset lower TV margins (12% EBITDA) and drive net margin expansion.</a:t>
+            </a:r>
+          </a:p>
+          <a:p>
+            <a:pPr>
+              <a:spcAft>
+                <a:spcPts val="600"/>
+              </a:spcAft>
+              <a:defRPr sz="900" b="0">
+                <a:solidFill>
+                  <a:srgbClr val="212121"/>
+                </a:solidFill>
+                <a:latin typeface="Arial"/>
+              </a:defRPr>
+            </a:pPr>
+            <a:r>
+              <a:t>• Churn Leverage: Reducing household churn from 22% down to 5% lifts customer lifetime value (LTV) by over 400%, easily amortizing the initial ₹999/mo introductory launch promo cost.</a:t>
+            </a:r>
+          </a:p>
+        </p:txBody>
+      </p:sp>
+      <p:sp>
+        <p:nvSpPr>
+          <p:cNvPr id="13" name="Rectangle 12"/>
+          <p:cNvSpPr/>
+          <p:nvPr/>
+        </p:nvSpPr>
+        <p:spPr>
+          <a:xfrm>
+            <a:off x="502920" y="1005840"/>
+            <a:ext cx="8138160" cy="73152"/>
+          </a:xfrm>
+          <a:prstGeom prst="rect">
+            <a:avLst/>
+          </a:prstGeom>
+          <a:solidFill>
+            <a:srgbClr val="ED1D24"/>
+          </a:solidFill>
+          <a:ln>
+            <a:noFill/>
+          </a:ln>
+        </p:spPr>
+        <p:style>
+          <a:lnRef idx="1">
+            <a:schemeClr val="accent1"/>
+          </a:lnRef>
+          <a:fillRef idx="3">
+            <a:schemeClr val="accent1"/>
+          </a:fillRef>
+          <a:effectRef idx="2">
+            <a:schemeClr val="accent1"/>
+          </a:effectRef>
+          <a:fontRef idx="minor">
+            <a:schemeClr val="lt1"/>
+          </a:fontRef>
+        </p:style>
+        <p:txBody>
+          <a:bodyPr rtlCol="0" anchor="ctr"/>
+          <a:lstStyle/>
+          <a:p>
+            <a:pPr algn="ctr"/>
           </a:p>
         </p:txBody>
       </p:sp>
@@ -8632,145 +8391,6 @@
           </a:prstGeom>
         </p:spPr>
       </p:pic>
-      <p:sp>
-        <p:nvSpPr>
-          <p:cNvPr id="4" name="TextBox 3"/>
-          <p:cNvSpPr txBox="1"/>
-          <p:nvPr/>
-        </p:nvSpPr>
-        <p:spPr>
-          <a:xfrm>
-            <a:off x="457200" y="182880"/>
-            <a:ext cx="8229600" cy="731520"/>
-          </a:xfrm>
-          <a:prstGeom prst="rect">
-            <a:avLst/>
-          </a:prstGeom>
-          <a:noFill/>
-        </p:spPr>
-        <p:txBody>
-          <a:bodyPr wrap="square" lIns="0" tIns="0">
-            <a:spAutoFit/>
-          </a:bodyPr>
-          <a:lstStyle/>
-          <a:p>
-            <a:pPr>
-              <a:defRPr sz="2100" b="1">
-                <a:solidFill>
-                  <a:srgbClr val="ED1D24"/>
-                </a:solidFill>
-                <a:latin typeface="Calibri"/>
-              </a:defRPr>
-            </a:pPr>
-            <a:r>
-              <a:t>Annexure 1: Primary Research &amp; Conjoint Choice Cards</a:t>
-            </a:r>
-          </a:p>
-        </p:txBody>
-      </p:sp>
-      <p:sp>
-        <p:nvSpPr>
-          <p:cNvPr id="5" name="TextBox 4"/>
-          <p:cNvSpPr txBox="1"/>
-          <p:nvPr/>
-        </p:nvSpPr>
-        <p:spPr>
-          <a:xfrm>
-            <a:off x="457200" y="1005840"/>
-            <a:ext cx="3840480" cy="3657600"/>
-          </a:xfrm>
-          <a:prstGeom prst="rect">
-            <a:avLst/>
-          </a:prstGeom>
-          <a:noFill/>
-        </p:spPr>
-        <p:txBody>
-          <a:bodyPr wrap="square" lIns="0" tIns="0">
-            <a:spAutoFit/>
-          </a:bodyPr>
-          <a:lstStyle/>
-          <a:p>
-            <a:pPr>
-              <a:spcAft>
-                <a:spcPts val="800"/>
-              </a:spcAft>
-              <a:defRPr sz="1300" b="1">
-                <a:solidFill>
-                  <a:srgbClr val="0F121C"/>
-                </a:solidFill>
-                <a:latin typeface="Calibri"/>
-              </a:defRPr>
-            </a:pPr>
-            <a:r>
-              <a:t>Research Methodology &amp; Conjoint Analysis</a:t>
-            </a:r>
-          </a:p>
-          <a:p>
-            <a:pPr>
-              <a:spcAft>
-                <a:spcPts val="600"/>
-              </a:spcAft>
-              <a:defRPr sz="950" b="0">
-                <a:solidFill>
-                  <a:srgbClr val="212121"/>
-                </a:solidFill>
-                <a:latin typeface="Arial"/>
-              </a:defRPr>
-            </a:pPr>
-            <a:r>
-              <a:t>• Conjoint Setup: We deployed 4 binary choice questions directly comparing individual utilities vs. their bundled Altura Home counterparts (Choice Card Starter, Connect, Family Secure, and Infinite).</a:t>
-            </a:r>
-          </a:p>
-          <a:p>
-            <a:pPr>
-              <a:spcAft>
-                <a:spcPts val="600"/>
-              </a:spcAft>
-              <a:defRPr sz="950" b="0">
-                <a:solidFill>
-                  <a:srgbClr val="212121"/>
-                </a:solidFill>
-                <a:latin typeface="Arial"/>
-              </a:defRPr>
-            </a:pPr>
-            <a:r>
-              <a:t>• Goal: This Discrete Choice Conjoint Experiment isolates exactly where price sensitivity breaks and maps household utility values.</a:t>
-            </a:r>
-          </a:p>
-          <a:p>
-            <a:pPr>
-              <a:spcAft>
-                <a:spcPts val="600"/>
-              </a:spcAft>
-              <a:defRPr sz="950" b="0">
-                <a:solidFill>
-                  <a:srgbClr val="212121"/>
-                </a:solidFill>
-                <a:latin typeface="Arial"/>
-              </a:defRPr>
-            </a:pPr>
-            <a:r>
-              <a:t>• Quantifying SPOF: Our survey includes agree/disagree statements to map network reliability concerns and data privacy barriers.</a:t>
-            </a:r>
-          </a:p>
-          <a:p>
-            <a:pPr>
-              <a:spcAft>
-                <a:spcPts val="600"/>
-              </a:spcAft>
-              <a:defRPr sz="950" b="0">
-                <a:solidFill>
-                  <a:srgbClr val="212121"/>
-                </a:solidFill>
-                <a:latin typeface="Arial"/>
-              </a:defRPr>
-            </a:pPr>
-            <a:r>
-              <a:t>• Uploading Cards: The generated card graphics (pictured right) help respondents visually compare price-to-benefit ratios.</a:t>
-            </a:r>
-          </a:p>
-        </p:txBody>
-      </p:sp>
       <p:pic>
         <p:nvPicPr>
           <p:cNvPr id="6" name="Picture 5" descr="image.jpg"/>

</xml_diff>

<commit_message>
Update table headers to Jio and VI on Slide 2
</commit_message>
<xml_diff>
--- a/Altura_Household_Convergence_Strategy.pptx
+++ b/Altura_Household_Convergence_Strategy.pptx
@@ -8074,7 +8074,7 @@
                         </a:defRPr>
                       </a:pPr>
                       <a:r>
-                        <a:t>Scale Rival</a:t>
+                        <a:t>Jio</a:t>
                       </a:r>
                     </a:p>
                   </a:txBody>
@@ -8098,7 +8098,7 @@
                         </a:defRPr>
                       </a:pPr>
                       <a:r>
-                        <a:t>Value Chall.</a:t>
+                        <a:t>VI</a:t>
                       </a:r>
                     </a:p>
                   </a:txBody>

</xml_diff>